<commit_message>
style: adopt neutral palette and readable crosstab values
</commit_message>
<xml_diff>
--- a/tests/fixtures/export/sleep-report.pptx
+++ b/tests/fixtures/export/sleep-report.pptx
@@ -1340,11 +1340,11 @@
             <a:r>
               <a:rPr lang="en-US" sz="2800" b="1" dirty="0">
                 <a:solidFill>
-                  <a:srgbClr val="1C1C1C"/>
+                  <a:srgbClr val="17212B"/>
                 </a:solidFill>
-                <a:latin typeface="Atkinson Hyperlegible" pitchFamily="34" charset="0"/>
-                <a:ea typeface="Atkinson Hyperlegible" pitchFamily="34" charset="-122"/>
-                <a:cs typeface="Atkinson Hyperlegible" pitchFamily="34" charset="-120"/>
+                <a:latin typeface="Arial" pitchFamily="34" charset="0"/>
+                <a:ea typeface="Arial" pitchFamily="34" charset="-122"/>
+                <a:cs typeface="Arial" pitchFamily="34" charset="-120"/>
               </a:rPr>
               <a:t>Sleep Health Report — Key Findings</a:t>
             </a:r>
@@ -1404,11 +1404,11 @@
             <a:r>
               <a:rPr lang="en-US" sz="2800" b="1" dirty="0">
                 <a:solidFill>
-                  <a:srgbClr val="E07A5F"/>
+                  <a:srgbClr val="245FA7"/>
                 </a:solidFill>
-                <a:latin typeface="Atkinson Hyperlegible" pitchFamily="34" charset="0"/>
-                <a:ea typeface="Atkinson Hyperlegible" pitchFamily="34" charset="-122"/>
-                <a:cs typeface="Atkinson Hyperlegible" pitchFamily="34" charset="-120"/>
+                <a:latin typeface="Arial" pitchFamily="34" charset="0"/>
+                <a:ea typeface="Arial" pitchFamily="34" charset="-122"/>
+                <a:cs typeface="Arial" pitchFamily="34" charset="-120"/>
               </a:rPr>
               <a:t>Sleep Quality</a:t>
             </a:r>
@@ -1443,11 +1443,11 @@
             <a:r>
               <a:rPr lang="en-US" sz="1100" dirty="0">
                 <a:solidFill>
-                  <a:srgbClr val="1C1C1C"/>
+                  <a:srgbClr val="17212B"/>
                 </a:solidFill>
-                <a:latin typeface="Atkinson Hyperlegible" pitchFamily="34" charset="0"/>
-                <a:ea typeface="Atkinson Hyperlegible" pitchFamily="34" charset="-122"/>
-                <a:cs typeface="Atkinson Hyperlegible" pitchFamily="34" charset="-120"/>
+                <a:latin typeface="Arial" pitchFamily="34" charset="0"/>
+                <a:ea typeface="Arial" pitchFamily="34" charset="-122"/>
+                <a:cs typeface="Arial" pitchFamily="34" charset="-120"/>
               </a:rPr>
               <a:t>Section Divider</a:t>
             </a:r>
@@ -1507,11 +1507,11 @@
             <a:r>
               <a:rPr lang="en-US" sz="1800" b="1" dirty="0">
                 <a:solidFill>
-                  <a:srgbClr val="1C1C1C"/>
+                  <a:srgbClr val="17212B"/>
                 </a:solidFill>
-                <a:latin typeface="Atkinson Hyperlegible" pitchFamily="34" charset="0"/>
-                <a:ea typeface="Atkinson Hyperlegible" pitchFamily="34" charset="-122"/>
-                <a:cs typeface="Atkinson Hyperlegible" pitchFamily="34" charset="-120"/>
+                <a:latin typeface="Arial" pitchFamily="34" charset="0"/>
+                <a:ea typeface="Arial" pitchFamily="34" charset="-122"/>
+                <a:cs typeface="Arial" pitchFamily="34" charset="-120"/>
               </a:rPr>
               <a:t>Quality of Sleep by Gender</a:t>
             </a:r>
@@ -1548,9 +1548,9 @@
                 <a:solidFill>
                   <a:srgbClr val="666666"/>
                 </a:solidFill>
-                <a:latin typeface="Atkinson Hyperlegible" pitchFamily="34" charset="0"/>
-                <a:ea typeface="Atkinson Hyperlegible" pitchFamily="34" charset="-122"/>
-                <a:cs typeface="Atkinson Hyperlegible" pitchFamily="34" charset="-120"/>
+                <a:latin typeface="Arial" pitchFamily="34" charset="0"/>
+                <a:ea typeface="Arial" pitchFamily="34" charset="-122"/>
+                <a:cs typeface="Arial" pitchFamily="34" charset="-120"/>
               </a:rPr>
               <a:t>N = 271 Respondents</a:t>
             </a:r>
@@ -1595,9 +1595,9 @@
                         <a:buNone/>
                       </a:pPr>
                       <a:endParaRPr lang="en-US" sz="1000" dirty="0">
-                        <a:latin typeface="Atkinson Hyperlegible" charset="0"/>
-                        <a:ea typeface="Atkinson Hyperlegible" charset="0"/>
-                        <a:cs typeface="Atkinson Hyperlegible" charset="0"/>
+                        <a:latin typeface="Arial" charset="0"/>
+                        <a:ea typeface="Arial" charset="0"/>
+                        <a:cs typeface="Arial" charset="0"/>
                       </a:endParaRPr>
                     </a:p>
                   </a:txBody>
@@ -1639,7 +1639,7 @@
                       <a:tailEnd type="none" w="med" len="med"/>
                     </a:lnB>
                     <a:solidFill>
-                      <a:srgbClr val="E07A5F"/>
+                      <a:srgbClr val="245FA7"/>
                     </a:solidFill>
                   </a:tcPr>
                 </a:tc>
@@ -1656,16 +1656,16 @@
                           <a:solidFill>
                             <a:srgbClr val="FFFFFF"/>
                           </a:solidFill>
-                          <a:latin typeface="Atkinson Hyperlegible" pitchFamily="34" charset="0"/>
-                          <a:ea typeface="Atkinson Hyperlegible" pitchFamily="34" charset="-122"/>
-                          <a:cs typeface="Atkinson Hyperlegible" pitchFamily="34" charset="-120"/>
+                          <a:latin typeface="Arial" pitchFamily="34" charset="0"/>
+                          <a:ea typeface="Arial" pitchFamily="34" charset="-122"/>
+                          <a:cs typeface="Arial" pitchFamily="34" charset="-120"/>
                         </a:rPr>
                         <a:t>female</a:t>
                       </a:r>
                       <a:endParaRPr lang="en-US" sz="1000" dirty="0">
-                        <a:latin typeface="Atkinson Hyperlegible" charset="0"/>
-                        <a:ea typeface="Atkinson Hyperlegible" charset="0"/>
-                        <a:cs typeface="Atkinson Hyperlegible" charset="0"/>
+                        <a:latin typeface="Arial" charset="0"/>
+                        <a:ea typeface="Arial" charset="0"/>
+                        <a:cs typeface="Arial" charset="0"/>
                       </a:endParaRPr>
                     </a:p>
                   </a:txBody>
@@ -1707,7 +1707,7 @@
                       <a:tailEnd type="none" w="med" len="med"/>
                     </a:lnB>
                     <a:solidFill>
-                      <a:srgbClr val="E07A5F"/>
+                      <a:srgbClr val="245FA7"/>
                     </a:solidFill>
                   </a:tcPr>
                 </a:tc>
@@ -1724,16 +1724,16 @@
                           <a:solidFill>
                             <a:srgbClr val="FFFFFF"/>
                           </a:solidFill>
-                          <a:latin typeface="Atkinson Hyperlegible" pitchFamily="34" charset="0"/>
-                          <a:ea typeface="Atkinson Hyperlegible" pitchFamily="34" charset="-122"/>
-                          <a:cs typeface="Atkinson Hyperlegible" pitchFamily="34" charset="-120"/>
+                          <a:latin typeface="Arial" pitchFamily="34" charset="0"/>
+                          <a:ea typeface="Arial" pitchFamily="34" charset="-122"/>
+                          <a:cs typeface="Arial" pitchFamily="34" charset="-120"/>
                         </a:rPr>
                         <a:t>male</a:t>
                       </a:r>
                       <a:endParaRPr lang="en-US" sz="1000" dirty="0">
-                        <a:latin typeface="Atkinson Hyperlegible" charset="0"/>
-                        <a:ea typeface="Atkinson Hyperlegible" charset="0"/>
-                        <a:cs typeface="Atkinson Hyperlegible" charset="0"/>
+                        <a:latin typeface="Arial" charset="0"/>
+                        <a:ea typeface="Arial" charset="0"/>
+                        <a:cs typeface="Arial" charset="0"/>
                       </a:endParaRPr>
                     </a:p>
                   </a:txBody>
@@ -1775,7 +1775,7 @@
                       <a:tailEnd type="none" w="med" len="med"/>
                     </a:lnB>
                     <a:solidFill>
-                      <a:srgbClr val="E07A5F"/>
+                      <a:srgbClr val="245FA7"/>
                     </a:solidFill>
                   </a:tcPr>
                 </a:tc>
@@ -1794,9 +1794,9 @@
                           <a:solidFill>
                             <a:srgbClr val="000000"/>
                           </a:solidFill>
-                          <a:latin typeface="Atkinson Hyperlegible" pitchFamily="34" charset="0"/>
-                          <a:ea typeface="Atkinson Hyperlegible" pitchFamily="34" charset="-122"/>
-                          <a:cs typeface="Atkinson Hyperlegible" pitchFamily="34" charset="-120"/>
+                          <a:latin typeface="Arial" pitchFamily="34" charset="0"/>
+                          <a:ea typeface="Arial" pitchFamily="34" charset="-122"/>
+                          <a:cs typeface="Arial" pitchFamily="34" charset="-120"/>
                         </a:rPr>
                         <a:t>very </a:t>
                       </a:r>
@@ -1808,16 +1808,16 @@
                           <a:solidFill>
                             <a:srgbClr val="000000"/>
                           </a:solidFill>
-                          <a:latin typeface="Atkinson Hyperlegible" pitchFamily="34" charset="0"/>
-                          <a:ea typeface="Atkinson Hyperlegible" pitchFamily="34" charset="-122"/>
-                          <a:cs typeface="Atkinson Hyperlegible" pitchFamily="34" charset="-120"/>
+                          <a:latin typeface="Arial" pitchFamily="34" charset="0"/>
+                          <a:ea typeface="Arial" pitchFamily="34" charset="-122"/>
+                          <a:cs typeface="Arial" pitchFamily="34" charset="-120"/>
                         </a:rPr>
                         <a:t>poor</a:t>
                       </a:r>
                       <a:endParaRPr lang="en-US" sz="900" dirty="0">
-                        <a:latin typeface="Atkinson Hyperlegible" charset="0"/>
-                        <a:ea typeface="Atkinson Hyperlegible" charset="0"/>
-                        <a:cs typeface="Atkinson Hyperlegible" charset="0"/>
+                        <a:latin typeface="Arial" charset="0"/>
+                        <a:ea typeface="Arial" charset="0"/>
+                        <a:cs typeface="Arial" charset="0"/>
                       </a:endParaRPr>
                     </a:p>
                   </a:txBody>
@@ -1873,16 +1873,16 @@
                           <a:solidFill>
                             <a:srgbClr val="000000"/>
                           </a:solidFill>
-                          <a:latin typeface="Atkinson Hyperlegible" pitchFamily="34" charset="0"/>
-                          <a:ea typeface="Atkinson Hyperlegible" pitchFamily="34" charset="-122"/>
-                          <a:cs typeface="Atkinson Hyperlegible" pitchFamily="34" charset="-120"/>
+                          <a:latin typeface="Arial" pitchFamily="34" charset="0"/>
+                          <a:ea typeface="Arial" pitchFamily="34" charset="-122"/>
+                          <a:cs typeface="Arial" pitchFamily="34" charset="-120"/>
                         </a:rPr>
                         <a:t>5.3%</a:t>
                       </a:r>
                       <a:endParaRPr lang="en-US" sz="900" dirty="0">
-                        <a:latin typeface="Atkinson Hyperlegible" charset="0"/>
-                        <a:ea typeface="Atkinson Hyperlegible" charset="0"/>
-                        <a:cs typeface="Atkinson Hyperlegible" charset="0"/>
+                        <a:latin typeface="Arial" charset="0"/>
+                        <a:ea typeface="Arial" charset="0"/>
+                        <a:cs typeface="Arial" charset="0"/>
                       </a:endParaRPr>
                     </a:p>
                   </a:txBody>
@@ -1938,16 +1938,16 @@
                           <a:solidFill>
                             <a:srgbClr val="000000"/>
                           </a:solidFill>
-                          <a:latin typeface="Atkinson Hyperlegible" pitchFamily="34" charset="0"/>
-                          <a:ea typeface="Atkinson Hyperlegible" pitchFamily="34" charset="-122"/>
-                          <a:cs typeface="Atkinson Hyperlegible" pitchFamily="34" charset="-120"/>
+                          <a:latin typeface="Arial" pitchFamily="34" charset="0"/>
+                          <a:ea typeface="Arial" pitchFamily="34" charset="-122"/>
+                          <a:cs typeface="Arial" pitchFamily="34" charset="-120"/>
                         </a:rPr>
                         <a:t>2.5%</a:t>
                       </a:r>
                       <a:endParaRPr lang="en-US" sz="900" dirty="0">
-                        <a:latin typeface="Atkinson Hyperlegible" charset="0"/>
-                        <a:ea typeface="Atkinson Hyperlegible" charset="0"/>
-                        <a:cs typeface="Atkinson Hyperlegible" charset="0"/>
+                        <a:latin typeface="Arial" charset="0"/>
+                        <a:ea typeface="Arial" charset="0"/>
+                        <a:cs typeface="Arial" charset="0"/>
                       </a:endParaRPr>
                     </a:p>
                   </a:txBody>
@@ -2005,16 +2005,16 @@
                           <a:solidFill>
                             <a:srgbClr val="000000"/>
                           </a:solidFill>
-                          <a:latin typeface="Atkinson Hyperlegible" pitchFamily="34" charset="0"/>
-                          <a:ea typeface="Atkinson Hyperlegible" pitchFamily="34" charset="-122"/>
-                          <a:cs typeface="Atkinson Hyperlegible" pitchFamily="34" charset="-120"/>
+                          <a:latin typeface="Arial" pitchFamily="34" charset="0"/>
+                          <a:ea typeface="Arial" pitchFamily="34" charset="-122"/>
+                          <a:cs typeface="Arial" pitchFamily="34" charset="-120"/>
                         </a:rPr>
                         <a:t>poor</a:t>
                       </a:r>
                       <a:endParaRPr lang="en-US" sz="900" dirty="0">
-                        <a:latin typeface="Atkinson Hyperlegible" charset="0"/>
-                        <a:ea typeface="Atkinson Hyperlegible" charset="0"/>
-                        <a:cs typeface="Atkinson Hyperlegible" charset="0"/>
+                        <a:latin typeface="Arial" charset="0"/>
+                        <a:ea typeface="Arial" charset="0"/>
+                        <a:cs typeface="Arial" charset="0"/>
                       </a:endParaRPr>
                     </a:p>
                   </a:txBody>
@@ -2070,16 +2070,16 @@
                           <a:solidFill>
                             <a:srgbClr val="000000"/>
                           </a:solidFill>
-                          <a:latin typeface="Atkinson Hyperlegible" pitchFamily="34" charset="0"/>
-                          <a:ea typeface="Atkinson Hyperlegible" pitchFamily="34" charset="-122"/>
-                          <a:cs typeface="Atkinson Hyperlegible" pitchFamily="34" charset="-120"/>
+                          <a:latin typeface="Arial" pitchFamily="34" charset="0"/>
+                          <a:ea typeface="Arial" pitchFamily="34" charset="-122"/>
+                          <a:cs typeface="Arial" pitchFamily="34" charset="-120"/>
                         </a:rPr>
                         <a:t>7.3%</a:t>
                       </a:r>
                       <a:endParaRPr lang="en-US" sz="900" dirty="0">
-                        <a:latin typeface="Atkinson Hyperlegible" charset="0"/>
-                        <a:ea typeface="Atkinson Hyperlegible" charset="0"/>
-                        <a:cs typeface="Atkinson Hyperlegible" charset="0"/>
+                        <a:latin typeface="Arial" charset="0"/>
+                        <a:ea typeface="Arial" charset="0"/>
+                        <a:cs typeface="Arial" charset="0"/>
                       </a:endParaRPr>
                     </a:p>
                   </a:txBody>
@@ -2135,16 +2135,16 @@
                           <a:solidFill>
                             <a:srgbClr val="000000"/>
                           </a:solidFill>
-                          <a:latin typeface="Atkinson Hyperlegible" pitchFamily="34" charset="0"/>
-                          <a:ea typeface="Atkinson Hyperlegible" pitchFamily="34" charset="-122"/>
-                          <a:cs typeface="Atkinson Hyperlegible" pitchFamily="34" charset="-120"/>
+                          <a:latin typeface="Arial" pitchFamily="34" charset="0"/>
+                          <a:ea typeface="Arial" pitchFamily="34" charset="-122"/>
+                          <a:cs typeface="Arial" pitchFamily="34" charset="-120"/>
                         </a:rPr>
                         <a:t>11.9%</a:t>
                       </a:r>
                       <a:endParaRPr lang="en-US" sz="900" dirty="0">
-                        <a:latin typeface="Atkinson Hyperlegible" charset="0"/>
-                        <a:ea typeface="Atkinson Hyperlegible" charset="0"/>
-                        <a:cs typeface="Atkinson Hyperlegible" charset="0"/>
+                        <a:latin typeface="Arial" charset="0"/>
+                        <a:ea typeface="Arial" charset="0"/>
+                        <a:cs typeface="Arial" charset="0"/>
                       </a:endParaRPr>
                     </a:p>
                   </a:txBody>
@@ -2202,16 +2202,16 @@
                           <a:solidFill>
                             <a:srgbClr val="000000"/>
                           </a:solidFill>
-                          <a:latin typeface="Atkinson Hyperlegible" pitchFamily="34" charset="0"/>
-                          <a:ea typeface="Atkinson Hyperlegible" pitchFamily="34" charset="-122"/>
-                          <a:cs typeface="Atkinson Hyperlegible" pitchFamily="34" charset="-120"/>
+                          <a:latin typeface="Arial" pitchFamily="34" charset="0"/>
+                          <a:ea typeface="Arial" pitchFamily="34" charset="-122"/>
+                          <a:cs typeface="Arial" pitchFamily="34" charset="-120"/>
                         </a:rPr>
                         <a:t>fair</a:t>
                       </a:r>
                       <a:endParaRPr lang="en-US" sz="900" dirty="0">
-                        <a:latin typeface="Atkinson Hyperlegible" charset="0"/>
-                        <a:ea typeface="Atkinson Hyperlegible" charset="0"/>
-                        <a:cs typeface="Atkinson Hyperlegible" charset="0"/>
+                        <a:latin typeface="Arial" charset="0"/>
+                        <a:ea typeface="Arial" charset="0"/>
+                        <a:cs typeface="Arial" charset="0"/>
                       </a:endParaRPr>
                     </a:p>
                   </a:txBody>
@@ -2267,16 +2267,16 @@
                           <a:solidFill>
                             <a:srgbClr val="000000"/>
                           </a:solidFill>
-                          <a:latin typeface="Atkinson Hyperlegible" pitchFamily="34" charset="0"/>
-                          <a:ea typeface="Atkinson Hyperlegible" pitchFamily="34" charset="-122"/>
-                          <a:cs typeface="Atkinson Hyperlegible" pitchFamily="34" charset="-120"/>
+                          <a:latin typeface="Arial" pitchFamily="34" charset="0"/>
+                          <a:ea typeface="Arial" pitchFamily="34" charset="-122"/>
+                          <a:cs typeface="Arial" pitchFamily="34" charset="-120"/>
                         </a:rPr>
                         <a:t>28.7%</a:t>
                       </a:r>
                       <a:endParaRPr lang="en-US" sz="900" dirty="0">
-                        <a:latin typeface="Atkinson Hyperlegible" charset="0"/>
-                        <a:ea typeface="Atkinson Hyperlegible" charset="0"/>
-                        <a:cs typeface="Atkinson Hyperlegible" charset="0"/>
+                        <a:latin typeface="Arial" charset="0"/>
+                        <a:ea typeface="Arial" charset="0"/>
+                        <a:cs typeface="Arial" charset="0"/>
                       </a:endParaRPr>
                     </a:p>
                   </a:txBody>
@@ -2332,16 +2332,16 @@
                           <a:solidFill>
                             <a:srgbClr val="000000"/>
                           </a:solidFill>
-                          <a:latin typeface="Atkinson Hyperlegible" pitchFamily="34" charset="0"/>
-                          <a:ea typeface="Atkinson Hyperlegible" pitchFamily="34" charset="-122"/>
-                          <a:cs typeface="Atkinson Hyperlegible" pitchFamily="34" charset="-120"/>
+                          <a:latin typeface="Arial" pitchFamily="34" charset="0"/>
+                          <a:ea typeface="Arial" pitchFamily="34" charset="-122"/>
+                          <a:cs typeface="Arial" pitchFamily="34" charset="-120"/>
                         </a:rPr>
                         <a:t>27.1%</a:t>
                       </a:r>
                       <a:endParaRPr lang="en-US" sz="900" dirty="0">
-                        <a:latin typeface="Atkinson Hyperlegible" charset="0"/>
-                        <a:ea typeface="Atkinson Hyperlegible" charset="0"/>
-                        <a:cs typeface="Atkinson Hyperlegible" charset="0"/>
+                        <a:latin typeface="Arial" charset="0"/>
+                        <a:ea typeface="Arial" charset="0"/>
+                        <a:cs typeface="Arial" charset="0"/>
                       </a:endParaRPr>
                     </a:p>
                   </a:txBody>
@@ -2399,16 +2399,16 @@
                           <a:solidFill>
                             <a:srgbClr val="000000"/>
                           </a:solidFill>
-                          <a:latin typeface="Atkinson Hyperlegible" pitchFamily="34" charset="0"/>
-                          <a:ea typeface="Atkinson Hyperlegible" pitchFamily="34" charset="-122"/>
-                          <a:cs typeface="Atkinson Hyperlegible" pitchFamily="34" charset="-120"/>
+                          <a:latin typeface="Arial" pitchFamily="34" charset="0"/>
+                          <a:ea typeface="Arial" pitchFamily="34" charset="-122"/>
+                          <a:cs typeface="Arial" pitchFamily="34" charset="-120"/>
                         </a:rPr>
                         <a:t>good</a:t>
                       </a:r>
                       <a:endParaRPr lang="en-US" sz="900" dirty="0">
-                        <a:latin typeface="Atkinson Hyperlegible" charset="0"/>
-                        <a:ea typeface="Atkinson Hyperlegible" charset="0"/>
-                        <a:cs typeface="Atkinson Hyperlegible" charset="0"/>
+                        <a:latin typeface="Arial" charset="0"/>
+                        <a:ea typeface="Arial" charset="0"/>
+                        <a:cs typeface="Arial" charset="0"/>
                       </a:endParaRPr>
                     </a:p>
                   </a:txBody>
@@ -2464,9 +2464,9 @@
                           <a:solidFill>
                             <a:srgbClr val="000000"/>
                           </a:solidFill>
-                          <a:latin typeface="Atkinson Hyperlegible" pitchFamily="34" charset="0"/>
-                          <a:ea typeface="Atkinson Hyperlegible" pitchFamily="34" charset="-122"/>
-                          <a:cs typeface="Atkinson Hyperlegible" pitchFamily="34" charset="-120"/>
+                          <a:latin typeface="Arial" pitchFamily="34" charset="0"/>
+                          <a:ea typeface="Arial" pitchFamily="34" charset="-122"/>
+                          <a:cs typeface="Arial" pitchFamily="34" charset="-120"/>
                         </a:rPr>
                         <a:t>38.0% </a:t>
                       </a:r>
@@ -2478,16 +2478,16 @@
                           <a:solidFill>
                             <a:srgbClr val="000000"/>
                           </a:solidFill>
-                          <a:latin typeface="Atkinson Hyperlegible" pitchFamily="34" charset="0"/>
-                          <a:ea typeface="Atkinson Hyperlegible" pitchFamily="34" charset="-122"/>
-                          <a:cs typeface="Atkinson Hyperlegible" pitchFamily="34" charset="-120"/>
+                          <a:latin typeface="Arial" pitchFamily="34" charset="0"/>
+                          <a:ea typeface="Arial" pitchFamily="34" charset="-122"/>
+                          <a:cs typeface="Arial" pitchFamily="34" charset="-120"/>
                         </a:rPr>
                         <a:t>△</a:t>
                       </a:r>
                       <a:endParaRPr lang="en-US" sz="900" dirty="0">
-                        <a:latin typeface="Atkinson Hyperlegible" charset="0"/>
-                        <a:ea typeface="Atkinson Hyperlegible" charset="0"/>
-                        <a:cs typeface="Atkinson Hyperlegible" charset="0"/>
+                        <a:latin typeface="Arial" charset="0"/>
+                        <a:ea typeface="Arial" charset="0"/>
+                        <a:cs typeface="Arial" charset="0"/>
                       </a:endParaRPr>
                     </a:p>
                   </a:txBody>
@@ -2543,16 +2543,16 @@
                           <a:solidFill>
                             <a:srgbClr val="000000"/>
                           </a:solidFill>
-                          <a:latin typeface="Atkinson Hyperlegible" pitchFamily="34" charset="0"/>
-                          <a:ea typeface="Atkinson Hyperlegible" pitchFamily="34" charset="-122"/>
-                          <a:cs typeface="Atkinson Hyperlegible" pitchFamily="34" charset="-120"/>
+                          <a:latin typeface="Arial" pitchFamily="34" charset="0"/>
+                          <a:ea typeface="Arial" pitchFamily="34" charset="-122"/>
+                          <a:cs typeface="Arial" pitchFamily="34" charset="-120"/>
                         </a:rPr>
                         <a:t>28.0%</a:t>
                       </a:r>
                       <a:endParaRPr lang="en-US" sz="900" dirty="0">
-                        <a:latin typeface="Atkinson Hyperlegible" charset="0"/>
-                        <a:ea typeface="Atkinson Hyperlegible" charset="0"/>
-                        <a:cs typeface="Atkinson Hyperlegible" charset="0"/>
+                        <a:latin typeface="Arial" charset="0"/>
+                        <a:ea typeface="Arial" charset="0"/>
+                        <a:cs typeface="Arial" charset="0"/>
                       </a:endParaRPr>
                     </a:p>
                   </a:txBody>
@@ -2610,9 +2610,9 @@
                           <a:solidFill>
                             <a:srgbClr val="000000"/>
                           </a:solidFill>
-                          <a:latin typeface="Atkinson Hyperlegible" pitchFamily="34" charset="0"/>
-                          <a:ea typeface="Atkinson Hyperlegible" pitchFamily="34" charset="-122"/>
-                          <a:cs typeface="Atkinson Hyperlegible" pitchFamily="34" charset="-120"/>
+                          <a:latin typeface="Arial" pitchFamily="34" charset="0"/>
+                          <a:ea typeface="Arial" pitchFamily="34" charset="-122"/>
+                          <a:cs typeface="Arial" pitchFamily="34" charset="-120"/>
                         </a:rPr>
                         <a:t>very </a:t>
                       </a:r>
@@ -2624,16 +2624,16 @@
                           <a:solidFill>
                             <a:srgbClr val="000000"/>
                           </a:solidFill>
-                          <a:latin typeface="Atkinson Hyperlegible" pitchFamily="34" charset="0"/>
-                          <a:ea typeface="Atkinson Hyperlegible" pitchFamily="34" charset="-122"/>
-                          <a:cs typeface="Atkinson Hyperlegible" pitchFamily="34" charset="-120"/>
+                          <a:latin typeface="Arial" pitchFamily="34" charset="0"/>
+                          <a:ea typeface="Arial" pitchFamily="34" charset="-122"/>
+                          <a:cs typeface="Arial" pitchFamily="34" charset="-120"/>
                         </a:rPr>
                         <a:t>good</a:t>
                       </a:r>
                       <a:endParaRPr lang="en-US" sz="900" dirty="0">
-                        <a:latin typeface="Atkinson Hyperlegible" charset="0"/>
-                        <a:ea typeface="Atkinson Hyperlegible" charset="0"/>
-                        <a:cs typeface="Atkinson Hyperlegible" charset="0"/>
+                        <a:latin typeface="Arial" charset="0"/>
+                        <a:ea typeface="Arial" charset="0"/>
+                        <a:cs typeface="Arial" charset="0"/>
                       </a:endParaRPr>
                     </a:p>
                   </a:txBody>
@@ -2689,16 +2689,16 @@
                           <a:solidFill>
                             <a:srgbClr val="000000"/>
                           </a:solidFill>
-                          <a:latin typeface="Atkinson Hyperlegible" pitchFamily="34" charset="0"/>
-                          <a:ea typeface="Atkinson Hyperlegible" pitchFamily="34" charset="-122"/>
-                          <a:cs typeface="Atkinson Hyperlegible" pitchFamily="34" charset="-120"/>
+                          <a:latin typeface="Arial" pitchFamily="34" charset="0"/>
+                          <a:ea typeface="Arial" pitchFamily="34" charset="-122"/>
+                          <a:cs typeface="Arial" pitchFamily="34" charset="-120"/>
                         </a:rPr>
                         <a:t>17.3%</a:t>
                       </a:r>
                       <a:endParaRPr lang="en-US" sz="900" dirty="0">
-                        <a:latin typeface="Atkinson Hyperlegible" charset="0"/>
-                        <a:ea typeface="Atkinson Hyperlegible" charset="0"/>
-                        <a:cs typeface="Atkinson Hyperlegible" charset="0"/>
+                        <a:latin typeface="Arial" charset="0"/>
+                        <a:ea typeface="Arial" charset="0"/>
+                        <a:cs typeface="Arial" charset="0"/>
                       </a:endParaRPr>
                     </a:p>
                   </a:txBody>
@@ -2754,16 +2754,16 @@
                           <a:solidFill>
                             <a:srgbClr val="000000"/>
                           </a:solidFill>
-                          <a:latin typeface="Atkinson Hyperlegible" pitchFamily="34" charset="0"/>
-                          <a:ea typeface="Atkinson Hyperlegible" pitchFamily="34" charset="-122"/>
-                          <a:cs typeface="Atkinson Hyperlegible" pitchFamily="34" charset="-120"/>
+                          <a:latin typeface="Arial" pitchFamily="34" charset="0"/>
+                          <a:ea typeface="Arial" pitchFamily="34" charset="-122"/>
+                          <a:cs typeface="Arial" pitchFamily="34" charset="-120"/>
                         </a:rPr>
                         <a:t>26.3%</a:t>
                       </a:r>
                       <a:endParaRPr lang="en-US" sz="900" dirty="0">
-                        <a:latin typeface="Atkinson Hyperlegible" charset="0"/>
-                        <a:ea typeface="Atkinson Hyperlegible" charset="0"/>
-                        <a:cs typeface="Atkinson Hyperlegible" charset="0"/>
+                        <a:latin typeface="Arial" charset="0"/>
+                        <a:ea typeface="Arial" charset="0"/>
+                        <a:cs typeface="Arial" charset="0"/>
                       </a:endParaRPr>
                     </a:p>
                   </a:txBody>
@@ -2821,16 +2821,16 @@
                           <a:solidFill>
                             <a:srgbClr val="000000"/>
                           </a:solidFill>
-                          <a:latin typeface="Atkinson Hyperlegible" pitchFamily="34" charset="0"/>
-                          <a:ea typeface="Atkinson Hyperlegible" pitchFamily="34" charset="-122"/>
-                          <a:cs typeface="Atkinson Hyperlegible" pitchFamily="34" charset="-120"/>
+                          <a:latin typeface="Arial" pitchFamily="34" charset="0"/>
+                          <a:ea typeface="Arial" pitchFamily="34" charset="-122"/>
+                          <a:cs typeface="Arial" pitchFamily="34" charset="-120"/>
                         </a:rPr>
                         <a:t>excellent</a:t>
                       </a:r>
                       <a:endParaRPr lang="en-US" sz="900" dirty="0">
-                        <a:latin typeface="Atkinson Hyperlegible" charset="0"/>
-                        <a:ea typeface="Atkinson Hyperlegible" charset="0"/>
-                        <a:cs typeface="Atkinson Hyperlegible" charset="0"/>
+                        <a:latin typeface="Arial" charset="0"/>
+                        <a:ea typeface="Arial" charset="0"/>
+                        <a:cs typeface="Arial" charset="0"/>
                       </a:endParaRPr>
                     </a:p>
                   </a:txBody>
@@ -2886,16 +2886,16 @@
                           <a:solidFill>
                             <a:srgbClr val="000000"/>
                           </a:solidFill>
-                          <a:latin typeface="Atkinson Hyperlegible" pitchFamily="34" charset="0"/>
-                          <a:ea typeface="Atkinson Hyperlegible" pitchFamily="34" charset="-122"/>
-                          <a:cs typeface="Atkinson Hyperlegible" pitchFamily="34" charset="-120"/>
+                          <a:latin typeface="Arial" pitchFamily="34" charset="0"/>
+                          <a:ea typeface="Arial" pitchFamily="34" charset="-122"/>
+                          <a:cs typeface="Arial" pitchFamily="34" charset="-120"/>
                         </a:rPr>
                         <a:t>3.3%</a:t>
                       </a:r>
                       <a:endParaRPr lang="en-US" sz="900" dirty="0">
-                        <a:latin typeface="Atkinson Hyperlegible" charset="0"/>
-                        <a:ea typeface="Atkinson Hyperlegible" charset="0"/>
-                        <a:cs typeface="Atkinson Hyperlegible" charset="0"/>
+                        <a:latin typeface="Arial" charset="0"/>
+                        <a:ea typeface="Arial" charset="0"/>
+                        <a:cs typeface="Arial" charset="0"/>
                       </a:endParaRPr>
                     </a:p>
                   </a:txBody>
@@ -2951,16 +2951,16 @@
                           <a:solidFill>
                             <a:srgbClr val="000000"/>
                           </a:solidFill>
-                          <a:latin typeface="Atkinson Hyperlegible" pitchFamily="34" charset="0"/>
-                          <a:ea typeface="Atkinson Hyperlegible" pitchFamily="34" charset="-122"/>
-                          <a:cs typeface="Atkinson Hyperlegible" pitchFamily="34" charset="-120"/>
+                          <a:latin typeface="Arial" pitchFamily="34" charset="0"/>
+                          <a:ea typeface="Arial" pitchFamily="34" charset="-122"/>
+                          <a:cs typeface="Arial" pitchFamily="34" charset="-120"/>
                         </a:rPr>
                         <a:t>4.2%</a:t>
                       </a:r>
                       <a:endParaRPr lang="en-US" sz="900" dirty="0">
-                        <a:latin typeface="Atkinson Hyperlegible" charset="0"/>
-                        <a:ea typeface="Atkinson Hyperlegible" charset="0"/>
-                        <a:cs typeface="Atkinson Hyperlegible" charset="0"/>
+                        <a:latin typeface="Arial" charset="0"/>
+                        <a:ea typeface="Arial" charset="0"/>
+                        <a:cs typeface="Arial" charset="0"/>
                       </a:endParaRPr>
                     </a:p>
                   </a:txBody>
@@ -3060,11 +3060,11 @@
             <a:r>
               <a:rPr lang="en-US" sz="1800" b="1" dirty="0">
                 <a:solidFill>
-                  <a:srgbClr val="1C1C1C"/>
+                  <a:srgbClr val="17212B"/>
                 </a:solidFill>
-                <a:latin typeface="Atkinson Hyperlegible" pitchFamily="34" charset="0"/>
-                <a:ea typeface="Atkinson Hyperlegible" pitchFamily="34" charset="-122"/>
-                <a:cs typeface="Atkinson Hyperlegible" pitchFamily="34" charset="-120"/>
+                <a:latin typeface="Arial" pitchFamily="34" charset="0"/>
+                <a:ea typeface="Arial" pitchFamily="34" charset="-122"/>
+                <a:cs typeface="Arial" pitchFamily="34" charset="-120"/>
               </a:rPr>
               <a:t>Epworth Sleepiness Scale by Marital Status</a:t>
             </a:r>
@@ -3101,9 +3101,9 @@
                 <a:solidFill>
                   <a:srgbClr val="666666"/>
                 </a:solidFill>
-                <a:latin typeface="Atkinson Hyperlegible" pitchFamily="34" charset="0"/>
-                <a:ea typeface="Atkinson Hyperlegible" pitchFamily="34" charset="-122"/>
-                <a:cs typeface="Atkinson Hyperlegible" pitchFamily="34" charset="-120"/>
+                <a:latin typeface="Arial" pitchFamily="34" charset="0"/>
+                <a:ea typeface="Arial" pitchFamily="34" charset="-122"/>
+                <a:cs typeface="Arial" pitchFamily="34" charset="-120"/>
               </a:rPr>
               <a:t>N = 271 Respondents</a:t>
             </a:r>
@@ -3147,9 +3147,9 @@
                         <a:buNone/>
                       </a:pPr>
                       <a:endParaRPr lang="en-US" sz="1000" dirty="0">
-                        <a:latin typeface="Atkinson Hyperlegible" charset="0"/>
-                        <a:ea typeface="Atkinson Hyperlegible" charset="0"/>
-                        <a:cs typeface="Atkinson Hyperlegible" charset="0"/>
+                        <a:latin typeface="Arial" charset="0"/>
+                        <a:ea typeface="Arial" charset="0"/>
+                        <a:cs typeface="Arial" charset="0"/>
                       </a:endParaRPr>
                     </a:p>
                   </a:txBody>
@@ -3191,7 +3191,7 @@
                       <a:tailEnd type="none" w="med" len="med"/>
                     </a:lnB>
                     <a:solidFill>
-                      <a:srgbClr val="E07A5F"/>
+                      <a:srgbClr val="245FA7"/>
                     </a:solidFill>
                   </a:tcPr>
                 </a:tc>
@@ -3208,9 +3208,9 @@
                           <a:solidFill>
                             <a:srgbClr val="FFFFFF"/>
                           </a:solidFill>
-                          <a:latin typeface="Atkinson Hyperlegible" pitchFamily="34" charset="0"/>
-                          <a:ea typeface="Atkinson Hyperlegible" pitchFamily="34" charset="-122"/>
-                          <a:cs typeface="Atkinson Hyperlegible" pitchFamily="34" charset="-120"/>
+                          <a:latin typeface="Arial" pitchFamily="34" charset="0"/>
+                          <a:ea typeface="Arial" pitchFamily="34" charset="-122"/>
+                          <a:cs typeface="Arial" pitchFamily="34" charset="-120"/>
                         </a:rPr>
                         <a:t>epworth </a:t>
                       </a:r>
@@ -3222,9 +3222,9 @@
                           <a:solidFill>
                             <a:srgbClr val="FFFFFF"/>
                           </a:solidFill>
-                          <a:latin typeface="Atkinson Hyperlegible" pitchFamily="34" charset="0"/>
-                          <a:ea typeface="Atkinson Hyperlegible" pitchFamily="34" charset="-122"/>
-                          <a:cs typeface="Atkinson Hyperlegible" pitchFamily="34" charset="-120"/>
+                          <a:latin typeface="Arial" pitchFamily="34" charset="0"/>
+                          <a:ea typeface="Arial" pitchFamily="34" charset="-122"/>
+                          <a:cs typeface="Arial" pitchFamily="34" charset="-120"/>
                         </a:rPr>
                         <a:t>sleepiness </a:t>
                       </a:r>
@@ -3236,16 +3236,16 @@
                           <a:solidFill>
                             <a:srgbClr val="FFFFFF"/>
                           </a:solidFill>
-                          <a:latin typeface="Atkinson Hyperlegible" pitchFamily="34" charset="0"/>
-                          <a:ea typeface="Atkinson Hyperlegible" pitchFamily="34" charset="-122"/>
-                          <a:cs typeface="Atkinson Hyperlegible" pitchFamily="34" charset="-120"/>
+                          <a:latin typeface="Arial" pitchFamily="34" charset="0"/>
+                          <a:ea typeface="Arial" pitchFamily="34" charset="-122"/>
+                          <a:cs typeface="Arial" pitchFamily="34" charset="-120"/>
                         </a:rPr>
                         <a:t>scale</a:t>
                       </a:r>
                       <a:endParaRPr lang="en-US" sz="1000" dirty="0">
-                        <a:latin typeface="Atkinson Hyperlegible" charset="0"/>
-                        <a:ea typeface="Atkinson Hyperlegible" charset="0"/>
-                        <a:cs typeface="Atkinson Hyperlegible" charset="0"/>
+                        <a:latin typeface="Arial" charset="0"/>
+                        <a:ea typeface="Arial" charset="0"/>
+                        <a:cs typeface="Arial" charset="0"/>
                       </a:endParaRPr>
                     </a:p>
                   </a:txBody>
@@ -3287,7 +3287,7 @@
                       <a:tailEnd type="none" w="med" len="med"/>
                     </a:lnB>
                     <a:solidFill>
-                      <a:srgbClr val="E07A5F"/>
+                      <a:srgbClr val="245FA7"/>
                     </a:solidFill>
                   </a:tcPr>
                 </a:tc>
@@ -3306,16 +3306,16 @@
                           <a:solidFill>
                             <a:srgbClr val="000000"/>
                           </a:solidFill>
-                          <a:latin typeface="Atkinson Hyperlegible" pitchFamily="34" charset="0"/>
-                          <a:ea typeface="Atkinson Hyperlegible" pitchFamily="34" charset="-122"/>
-                          <a:cs typeface="Atkinson Hyperlegible" pitchFamily="34" charset="-120"/>
+                          <a:latin typeface="Arial" pitchFamily="34" charset="0"/>
+                          <a:ea typeface="Arial" pitchFamily="34" charset="-122"/>
+                          <a:cs typeface="Arial" pitchFamily="34" charset="-120"/>
                         </a:rPr>
                         <a:t>1</a:t>
                       </a:r>
                       <a:endParaRPr lang="en-US" sz="900" dirty="0">
-                        <a:latin typeface="Atkinson Hyperlegible" charset="0"/>
-                        <a:ea typeface="Atkinson Hyperlegible" charset="0"/>
-                        <a:cs typeface="Atkinson Hyperlegible" charset="0"/>
+                        <a:latin typeface="Arial" charset="0"/>
+                        <a:ea typeface="Arial" charset="0"/>
+                        <a:cs typeface="Arial" charset="0"/>
                       </a:endParaRPr>
                     </a:p>
                   </a:txBody>
@@ -3371,16 +3371,16 @@
                           <a:solidFill>
                             <a:srgbClr val="000000"/>
                           </a:solidFill>
-                          <a:latin typeface="Atkinson Hyperlegible" pitchFamily="34" charset="0"/>
-                          <a:ea typeface="Atkinson Hyperlegible" pitchFamily="34" charset="-122"/>
-                          <a:cs typeface="Atkinson Hyperlegible" pitchFamily="34" charset="-120"/>
+                          <a:latin typeface="Arial" pitchFamily="34" charset="0"/>
+                          <a:ea typeface="Arial" pitchFamily="34" charset="-122"/>
+                          <a:cs typeface="Arial" pitchFamily="34" charset="-120"/>
                         </a:rPr>
                         <a:t>21.2%</a:t>
                       </a:r>
                       <a:endParaRPr lang="en-US" sz="900" dirty="0">
-                        <a:latin typeface="Atkinson Hyperlegible" charset="0"/>
-                        <a:ea typeface="Atkinson Hyperlegible" charset="0"/>
-                        <a:cs typeface="Atkinson Hyperlegible" charset="0"/>
+                        <a:latin typeface="Arial" charset="0"/>
+                        <a:ea typeface="Arial" charset="0"/>
+                        <a:cs typeface="Arial" charset="0"/>
                       </a:endParaRPr>
                     </a:p>
                   </a:txBody>
@@ -3438,16 +3438,16 @@
                           <a:solidFill>
                             <a:srgbClr val="000000"/>
                           </a:solidFill>
-                          <a:latin typeface="Atkinson Hyperlegible" pitchFamily="34" charset="0"/>
-                          <a:ea typeface="Atkinson Hyperlegible" pitchFamily="34" charset="-122"/>
-                          <a:cs typeface="Atkinson Hyperlegible" pitchFamily="34" charset="-120"/>
+                          <a:latin typeface="Arial" pitchFamily="34" charset="0"/>
+                          <a:ea typeface="Arial" pitchFamily="34" charset="-122"/>
+                          <a:cs typeface="Arial" pitchFamily="34" charset="-120"/>
                         </a:rPr>
                         <a:t>2</a:t>
                       </a:r>
                       <a:endParaRPr lang="en-US" sz="900" dirty="0">
-                        <a:latin typeface="Atkinson Hyperlegible" charset="0"/>
-                        <a:ea typeface="Atkinson Hyperlegible" charset="0"/>
-                        <a:cs typeface="Atkinson Hyperlegible" charset="0"/>
+                        <a:latin typeface="Arial" charset="0"/>
+                        <a:ea typeface="Arial" charset="0"/>
+                        <a:cs typeface="Arial" charset="0"/>
                       </a:endParaRPr>
                     </a:p>
                   </a:txBody>
@@ -3503,16 +3503,16 @@
                           <a:solidFill>
                             <a:srgbClr val="000000"/>
                           </a:solidFill>
-                          <a:latin typeface="Atkinson Hyperlegible" pitchFamily="34" charset="0"/>
-                          <a:ea typeface="Atkinson Hyperlegible" pitchFamily="34" charset="-122"/>
-                          <a:cs typeface="Atkinson Hyperlegible" pitchFamily="34" charset="-120"/>
+                          <a:latin typeface="Arial" pitchFamily="34" charset="0"/>
+                          <a:ea typeface="Arial" pitchFamily="34" charset="-122"/>
+                          <a:cs typeface="Arial" pitchFamily="34" charset="-120"/>
                         </a:rPr>
                         <a:t>69.0%</a:t>
                       </a:r>
                       <a:endParaRPr lang="en-US" sz="900" dirty="0">
-                        <a:latin typeface="Atkinson Hyperlegible" charset="0"/>
-                        <a:ea typeface="Atkinson Hyperlegible" charset="0"/>
-                        <a:cs typeface="Atkinson Hyperlegible" charset="0"/>
+                        <a:latin typeface="Arial" charset="0"/>
+                        <a:ea typeface="Arial" charset="0"/>
+                        <a:cs typeface="Arial" charset="0"/>
                       </a:endParaRPr>
                     </a:p>
                   </a:txBody>
@@ -3570,16 +3570,16 @@
                           <a:solidFill>
                             <a:srgbClr val="000000"/>
                           </a:solidFill>
-                          <a:latin typeface="Atkinson Hyperlegible" pitchFamily="34" charset="0"/>
-                          <a:ea typeface="Atkinson Hyperlegible" pitchFamily="34" charset="-122"/>
-                          <a:cs typeface="Atkinson Hyperlegible" pitchFamily="34" charset="-120"/>
+                          <a:latin typeface="Arial" pitchFamily="34" charset="0"/>
+                          <a:ea typeface="Arial" pitchFamily="34" charset="-122"/>
+                          <a:cs typeface="Arial" pitchFamily="34" charset="-120"/>
                         </a:rPr>
                         <a:t>3</a:t>
                       </a:r>
                       <a:endParaRPr lang="en-US" sz="900" dirty="0">
-                        <a:latin typeface="Atkinson Hyperlegible" charset="0"/>
-                        <a:ea typeface="Atkinson Hyperlegible" charset="0"/>
-                        <a:cs typeface="Atkinson Hyperlegible" charset="0"/>
+                        <a:latin typeface="Arial" charset="0"/>
+                        <a:ea typeface="Arial" charset="0"/>
+                        <a:cs typeface="Arial" charset="0"/>
                       </a:endParaRPr>
                     </a:p>
                   </a:txBody>
@@ -3635,16 +3635,16 @@
                           <a:solidFill>
                             <a:srgbClr val="000000"/>
                           </a:solidFill>
-                          <a:latin typeface="Atkinson Hyperlegible" pitchFamily="34" charset="0"/>
-                          <a:ea typeface="Atkinson Hyperlegible" pitchFamily="34" charset="-122"/>
-                          <a:cs typeface="Atkinson Hyperlegible" pitchFamily="34" charset="-120"/>
+                          <a:latin typeface="Arial" pitchFamily="34" charset="0"/>
+                          <a:ea typeface="Arial" pitchFamily="34" charset="-122"/>
+                          <a:cs typeface="Arial" pitchFamily="34" charset="-120"/>
                         </a:rPr>
                         <a:t>7.8%</a:t>
                       </a:r>
                       <a:endParaRPr lang="en-US" sz="900" dirty="0">
-                        <a:latin typeface="Atkinson Hyperlegible" charset="0"/>
-                        <a:ea typeface="Atkinson Hyperlegible" charset="0"/>
-                        <a:cs typeface="Atkinson Hyperlegible" charset="0"/>
+                        <a:latin typeface="Arial" charset="0"/>
+                        <a:ea typeface="Arial" charset="0"/>
+                        <a:cs typeface="Arial" charset="0"/>
                       </a:endParaRPr>
                     </a:p>
                   </a:txBody>
@@ -3702,16 +3702,16 @@
                           <a:solidFill>
                             <a:srgbClr val="000000"/>
                           </a:solidFill>
-                          <a:latin typeface="Atkinson Hyperlegible" pitchFamily="34" charset="0"/>
-                          <a:ea typeface="Atkinson Hyperlegible" pitchFamily="34" charset="-122"/>
-                          <a:cs typeface="Atkinson Hyperlegible" pitchFamily="34" charset="-120"/>
+                          <a:latin typeface="Arial" pitchFamily="34" charset="0"/>
+                          <a:ea typeface="Arial" pitchFamily="34" charset="-122"/>
+                          <a:cs typeface="Arial" pitchFamily="34" charset="-120"/>
                         </a:rPr>
                         <a:t>4</a:t>
                       </a:r>
                       <a:endParaRPr lang="en-US" sz="900" dirty="0">
-                        <a:latin typeface="Atkinson Hyperlegible" charset="0"/>
-                        <a:ea typeface="Atkinson Hyperlegible" charset="0"/>
-                        <a:cs typeface="Atkinson Hyperlegible" charset="0"/>
+                        <a:latin typeface="Arial" charset="0"/>
+                        <a:ea typeface="Arial" charset="0"/>
+                        <a:cs typeface="Arial" charset="0"/>
                       </a:endParaRPr>
                     </a:p>
                   </a:txBody>
@@ -3767,16 +3767,16 @@
                           <a:solidFill>
                             <a:srgbClr val="000000"/>
                           </a:solidFill>
-                          <a:latin typeface="Atkinson Hyperlegible" pitchFamily="34" charset="0"/>
-                          <a:ea typeface="Atkinson Hyperlegible" pitchFamily="34" charset="-122"/>
-                          <a:cs typeface="Atkinson Hyperlegible" pitchFamily="34" charset="-120"/>
+                          <a:latin typeface="Arial" pitchFamily="34" charset="0"/>
+                          <a:ea typeface="Arial" pitchFamily="34" charset="-122"/>
+                          <a:cs typeface="Arial" pitchFamily="34" charset="-120"/>
                         </a:rPr>
                         <a:t>2.0%</a:t>
                       </a:r>
                       <a:endParaRPr lang="en-US" sz="900" dirty="0">
-                        <a:latin typeface="Atkinson Hyperlegible" charset="0"/>
-                        <a:ea typeface="Atkinson Hyperlegible" charset="0"/>
-                        <a:cs typeface="Atkinson Hyperlegible" charset="0"/>
+                        <a:latin typeface="Arial" charset="0"/>
+                        <a:ea typeface="Arial" charset="0"/>
+                        <a:cs typeface="Arial" charset="0"/>
                       </a:endParaRPr>
                     </a:p>
                   </a:txBody>
@@ -3876,11 +3876,11 @@
             <a:r>
               <a:rPr lang="en-US" sz="2800" b="1" dirty="0">
                 <a:solidFill>
-                  <a:srgbClr val="E07A5F"/>
+                  <a:srgbClr val="245FA7"/>
                 </a:solidFill>
-                <a:latin typeface="Atkinson Hyperlegible" pitchFamily="34" charset="0"/>
-                <a:ea typeface="Atkinson Hyperlegible" pitchFamily="34" charset="-122"/>
-                <a:cs typeface="Atkinson Hyperlegible" pitchFamily="34" charset="-120"/>
+                <a:latin typeface="Arial" pitchFamily="34" charset="0"/>
+                <a:ea typeface="Arial" pitchFamily="34" charset="-122"/>
+                <a:cs typeface="Arial" pitchFamily="34" charset="-120"/>
               </a:rPr>
               <a:t>Mental Health</a:t>
             </a:r>
@@ -3915,11 +3915,11 @@
             <a:r>
               <a:rPr lang="en-US" sz="1100" dirty="0">
                 <a:solidFill>
-                  <a:srgbClr val="1C1C1C"/>
+                  <a:srgbClr val="17212B"/>
                 </a:solidFill>
-                <a:latin typeface="Atkinson Hyperlegible" pitchFamily="34" charset="0"/>
-                <a:ea typeface="Atkinson Hyperlegible" pitchFamily="34" charset="-122"/>
-                <a:cs typeface="Atkinson Hyperlegible" pitchFamily="34" charset="-120"/>
+                <a:latin typeface="Arial" pitchFamily="34" charset="0"/>
+                <a:ea typeface="Arial" pitchFamily="34" charset="-122"/>
+                <a:cs typeface="Arial" pitchFamily="34" charset="-120"/>
               </a:rPr>
               <a:t>Section Divider</a:t>
             </a:r>
@@ -3979,11 +3979,11 @@
             <a:r>
               <a:rPr lang="en-US" sz="1800" b="1" dirty="0">
                 <a:solidFill>
-                  <a:srgbClr val="1C1C1C"/>
+                  <a:srgbClr val="17212B"/>
                 </a:solidFill>
-                <a:latin typeface="Atkinson Hyperlegible" pitchFamily="34" charset="0"/>
-                <a:ea typeface="Atkinson Hyperlegible" pitchFamily="34" charset="-122"/>
-                <a:cs typeface="Atkinson Hyperlegible" pitchFamily="34" charset="-120"/>
+                <a:latin typeface="Arial" pitchFamily="34" charset="0"/>
+                <a:ea typeface="Arial" pitchFamily="34" charset="-122"/>
+                <a:cs typeface="Arial" pitchFamily="34" charset="-120"/>
               </a:rPr>
               <a:t>HADS Anxiety by Gender</a:t>
             </a:r>
@@ -4020,9 +4020,9 @@
                 <a:solidFill>
                   <a:srgbClr val="666666"/>
                 </a:solidFill>
-                <a:latin typeface="Atkinson Hyperlegible" pitchFamily="34" charset="0"/>
-                <a:ea typeface="Atkinson Hyperlegible" pitchFamily="34" charset="-122"/>
-                <a:cs typeface="Atkinson Hyperlegible" pitchFamily="34" charset="-120"/>
+                <a:latin typeface="Arial" pitchFamily="34" charset="0"/>
+                <a:ea typeface="Arial" pitchFamily="34" charset="-122"/>
+                <a:cs typeface="Arial" pitchFamily="34" charset="-120"/>
               </a:rPr>
               <a:t>N = 271 Respondents</a:t>
             </a:r>
@@ -4066,9 +4066,9 @@
                         <a:buNone/>
                       </a:pPr>
                       <a:endParaRPr lang="en-US" sz="1000" dirty="0">
-                        <a:latin typeface="Atkinson Hyperlegible" charset="0"/>
-                        <a:ea typeface="Atkinson Hyperlegible" charset="0"/>
-                        <a:cs typeface="Atkinson Hyperlegible" charset="0"/>
+                        <a:latin typeface="Arial" charset="0"/>
+                        <a:ea typeface="Arial" charset="0"/>
+                        <a:cs typeface="Arial" charset="0"/>
                       </a:endParaRPr>
                     </a:p>
                   </a:txBody>
@@ -4110,7 +4110,7 @@
                       <a:tailEnd type="none" w="med" len="med"/>
                     </a:lnB>
                     <a:solidFill>
-                      <a:srgbClr val="E07A5F"/>
+                      <a:srgbClr val="245FA7"/>
                     </a:solidFill>
                   </a:tcPr>
                 </a:tc>
@@ -4127,9 +4127,9 @@
                           <a:solidFill>
                             <a:srgbClr val="FFFFFF"/>
                           </a:solidFill>
-                          <a:latin typeface="Atkinson Hyperlegible" pitchFamily="34" charset="0"/>
-                          <a:ea typeface="Atkinson Hyperlegible" pitchFamily="34" charset="-122"/>
-                          <a:cs typeface="Atkinson Hyperlegible" pitchFamily="34" charset="-120"/>
+                          <a:latin typeface="Arial" pitchFamily="34" charset="0"/>
+                          <a:ea typeface="Arial" pitchFamily="34" charset="-122"/>
+                          <a:cs typeface="Arial" pitchFamily="34" charset="-120"/>
                         </a:rPr>
                         <a:t>HADS </a:t>
                       </a:r>
@@ -4141,16 +4141,16 @@
                           <a:solidFill>
                             <a:srgbClr val="FFFFFF"/>
                           </a:solidFill>
-                          <a:latin typeface="Atkinson Hyperlegible" pitchFamily="34" charset="0"/>
-                          <a:ea typeface="Atkinson Hyperlegible" pitchFamily="34" charset="-122"/>
-                          <a:cs typeface="Atkinson Hyperlegible" pitchFamily="34" charset="-120"/>
+                          <a:latin typeface="Arial" pitchFamily="34" charset="0"/>
+                          <a:ea typeface="Arial" pitchFamily="34" charset="-122"/>
+                          <a:cs typeface="Arial" pitchFamily="34" charset="-120"/>
                         </a:rPr>
                         <a:t>Anxiety</a:t>
                       </a:r>
                       <a:endParaRPr lang="en-US" sz="1000" dirty="0">
-                        <a:latin typeface="Atkinson Hyperlegible" charset="0"/>
-                        <a:ea typeface="Atkinson Hyperlegible" charset="0"/>
-                        <a:cs typeface="Atkinson Hyperlegible" charset="0"/>
+                        <a:latin typeface="Arial" charset="0"/>
+                        <a:ea typeface="Arial" charset="0"/>
+                        <a:cs typeface="Arial" charset="0"/>
                       </a:endParaRPr>
                     </a:p>
                   </a:txBody>
@@ -4192,7 +4192,7 @@
                       <a:tailEnd type="none" w="med" len="med"/>
                     </a:lnB>
                     <a:solidFill>
-                      <a:srgbClr val="E07A5F"/>
+                      <a:srgbClr val="245FA7"/>
                     </a:solidFill>
                   </a:tcPr>
                 </a:tc>
@@ -4211,16 +4211,16 @@
                           <a:solidFill>
                             <a:srgbClr val="000000"/>
                           </a:solidFill>
-                          <a:latin typeface="Atkinson Hyperlegible" pitchFamily="34" charset="0"/>
-                          <a:ea typeface="Atkinson Hyperlegible" pitchFamily="34" charset="-122"/>
-                          <a:cs typeface="Atkinson Hyperlegible" pitchFamily="34" charset="-120"/>
+                          <a:latin typeface="Arial" pitchFamily="34" charset="0"/>
+                          <a:ea typeface="Arial" pitchFamily="34" charset="-122"/>
+                          <a:cs typeface="Arial" pitchFamily="34" charset="-120"/>
                         </a:rPr>
                         <a:t>0</a:t>
                       </a:r>
                       <a:endParaRPr lang="en-US" sz="900" dirty="0">
-                        <a:latin typeface="Atkinson Hyperlegible" charset="0"/>
-                        <a:ea typeface="Atkinson Hyperlegible" charset="0"/>
-                        <a:cs typeface="Atkinson Hyperlegible" charset="0"/>
+                        <a:latin typeface="Arial" charset="0"/>
+                        <a:ea typeface="Arial" charset="0"/>
+                        <a:cs typeface="Arial" charset="0"/>
                       </a:endParaRPr>
                     </a:p>
                   </a:txBody>
@@ -4276,16 +4276,16 @@
                           <a:solidFill>
                             <a:srgbClr val="000000"/>
                           </a:solidFill>
-                          <a:latin typeface="Atkinson Hyperlegible" pitchFamily="34" charset="0"/>
-                          <a:ea typeface="Atkinson Hyperlegible" pitchFamily="34" charset="-122"/>
-                          <a:cs typeface="Atkinson Hyperlegible" pitchFamily="34" charset="-120"/>
+                          <a:latin typeface="Arial" pitchFamily="34" charset="0"/>
+                          <a:ea typeface="Arial" pitchFamily="34" charset="-122"/>
+                          <a:cs typeface="Arial" pitchFamily="34" charset="-120"/>
                         </a:rPr>
                         <a:t>54.9%</a:t>
                       </a:r>
                       <a:endParaRPr lang="en-US" sz="900" dirty="0">
-                        <a:latin typeface="Atkinson Hyperlegible" charset="0"/>
-                        <a:ea typeface="Atkinson Hyperlegible" charset="0"/>
-                        <a:cs typeface="Atkinson Hyperlegible" charset="0"/>
+                        <a:latin typeface="Arial" charset="0"/>
+                        <a:ea typeface="Arial" charset="0"/>
+                        <a:cs typeface="Arial" charset="0"/>
                       </a:endParaRPr>
                     </a:p>
                   </a:txBody>
@@ -4343,16 +4343,16 @@
                           <a:solidFill>
                             <a:srgbClr val="000000"/>
                           </a:solidFill>
-                          <a:latin typeface="Atkinson Hyperlegible" pitchFamily="34" charset="0"/>
-                          <a:ea typeface="Atkinson Hyperlegible" pitchFamily="34" charset="-122"/>
-                          <a:cs typeface="Atkinson Hyperlegible" pitchFamily="34" charset="-120"/>
+                          <a:latin typeface="Arial" pitchFamily="34" charset="0"/>
+                          <a:ea typeface="Arial" pitchFamily="34" charset="-122"/>
+                          <a:cs typeface="Arial" pitchFamily="34" charset="-120"/>
                         </a:rPr>
                         <a:t>1</a:t>
                       </a:r>
                       <a:endParaRPr lang="en-US" sz="900" dirty="0">
-                        <a:latin typeface="Atkinson Hyperlegible" charset="0"/>
-                        <a:ea typeface="Atkinson Hyperlegible" charset="0"/>
-                        <a:cs typeface="Atkinson Hyperlegible" charset="0"/>
+                        <a:latin typeface="Arial" charset="0"/>
+                        <a:ea typeface="Arial" charset="0"/>
+                        <a:cs typeface="Arial" charset="0"/>
                       </a:endParaRPr>
                     </a:p>
                   </a:txBody>
@@ -4408,16 +4408,16 @@
                           <a:solidFill>
                             <a:srgbClr val="000000"/>
                           </a:solidFill>
-                          <a:latin typeface="Atkinson Hyperlegible" pitchFamily="34" charset="0"/>
-                          <a:ea typeface="Atkinson Hyperlegible" pitchFamily="34" charset="-122"/>
-                          <a:cs typeface="Atkinson Hyperlegible" pitchFamily="34" charset="-120"/>
+                          <a:latin typeface="Arial" pitchFamily="34" charset="0"/>
+                          <a:ea typeface="Arial" pitchFamily="34" charset="-122"/>
+                          <a:cs typeface="Arial" pitchFamily="34" charset="-120"/>
                         </a:rPr>
                         <a:t>45.1%</a:t>
                       </a:r>
                       <a:endParaRPr lang="en-US" sz="900" dirty="0">
-                        <a:latin typeface="Atkinson Hyperlegible" charset="0"/>
-                        <a:ea typeface="Atkinson Hyperlegible" charset="0"/>
-                        <a:cs typeface="Atkinson Hyperlegible" charset="0"/>
+                        <a:latin typeface="Arial" charset="0"/>
+                        <a:ea typeface="Arial" charset="0"/>
+                        <a:cs typeface="Arial" charset="0"/>
                       </a:endParaRPr>
                     </a:p>
                   </a:txBody>

</xml_diff>

<commit_message>
Improve Track B export quality and evidence
</commit_message>
<xml_diff>
--- a/tests/fixtures/export/sleep-report.pptx
+++ b/tests/fixtures/export/sleep-report.pptx
@@ -1488,8 +1488,8 @@
         </p:nvSpPr>
         <p:spPr>
           <a:xfrm>
-            <a:off x="457200" y="274320"/>
-            <a:ext cx="10972800" cy="0"/>
+            <a:off x="640080" y="274320"/>
+            <a:ext cx="10881360" cy="822960"/>
           </a:xfrm>
           <a:prstGeom prst="rect">
             <a:avLst/>
@@ -1505,7 +1505,7 @@
               <a:buNone/>
             </a:pPr>
             <a:r>
-              <a:rPr lang="en-US" sz="1800" b="1" dirty="0">
+              <a:rPr lang="en-US" sz="2000" b="1" dirty="0">
                 <a:solidFill>
                   <a:srgbClr val="17212B"/>
                 </a:solidFill>
@@ -1515,7 +1515,7 @@
               </a:rPr>
               <a:t>Quality of Sleep by Gender</a:t>
             </a:r>
-            <a:endParaRPr lang="en-US" sz="1800" dirty="0"/>
+            <a:endParaRPr lang="en-US" sz="2000" dirty="0"/>
           </a:p>
         </p:txBody>
       </p:sp>
@@ -1527,8 +1527,8 @@
         </p:nvSpPr>
         <p:spPr>
           <a:xfrm>
-            <a:off x="457200" y="621792"/>
-            <a:ext cx="10972800" cy="0"/>
+            <a:off x="640080" y="6309360"/>
+            <a:ext cx="10881360" cy="347472"/>
           </a:xfrm>
           <a:prstGeom prst="rect">
             <a:avLst/>
@@ -1544,7 +1544,7 @@
               <a:buNone/>
             </a:pPr>
             <a:r>
-              <a:rPr lang="en-US" sz="1000" dirty="0">
+              <a:rPr lang="en-US" sz="900" dirty="0">
                 <a:solidFill>
                   <a:srgbClr val="666666"/>
                 </a:solidFill>
@@ -1554,7 +1554,7 @@
               </a:rPr>
               <a:t>N = 271 Respondents</a:t>
             </a:r>
-            <a:endParaRPr lang="en-US" sz="1000" dirty="0"/>
+            <a:endParaRPr lang="en-US" sz="900" dirty="0"/>
           </a:p>
         </p:txBody>
       </p:sp>
@@ -1573,19 +1573,19 @@
           </p:nvPr>
         </p:nvGraphicFramePr>
         <p:xfrm>
-          <a:off x="457200" y="1188720"/>
-          <a:ext cx="11247120" cy="914400"/>
+          <a:off x="640080" y="1600200"/>
+          <a:ext cx="8869680" cy="914400"/>
         </p:xfrm>
         <a:graphic>
           <a:graphicData uri="http://schemas.openxmlformats.org/drawingml/2006/table">
             <a:tbl>
               <a:tblPr/>
               <a:tblGrid>
-                <a:gridCol w="2743200"/>
-                <a:gridCol w="4251960"/>
-                <a:gridCol w="4251960"/>
+                <a:gridCol w="2926080"/>
+                <a:gridCol w="2971800"/>
+                <a:gridCol w="2971800"/>
               </a:tblGrid>
-              <a:tr h="320040">
+              <a:tr h="475488">
                 <a:tc>
                   <a:txBody>
                     <a:bodyPr/>
@@ -1594,7 +1594,7 @@
                       <a:pPr indent="0" marL="0">
                         <a:buNone/>
                       </a:pPr>
-                      <a:endParaRPr lang="en-US" sz="1000" dirty="0">
+                      <a:endParaRPr lang="en-US" sz="1100" dirty="0">
                         <a:latin typeface="Arial" charset="0"/>
                         <a:ea typeface="Arial" charset="0"/>
                         <a:cs typeface="Arial" charset="0"/>
@@ -1652,7 +1652,7 @@
                         <a:buNone/>
                       </a:pPr>
                       <a:r>
-                        <a:rPr lang="en-US" sz="1000" b="1" dirty="0">
+                        <a:rPr lang="en-US" sz="1100" b="1" dirty="0">
                           <a:solidFill>
                             <a:srgbClr val="FFFFFF"/>
                           </a:solidFill>
@@ -1662,7 +1662,7 @@
                         </a:rPr>
                         <a:t>female</a:t>
                       </a:r>
-                      <a:endParaRPr lang="en-US" sz="1000" dirty="0">
+                      <a:endParaRPr lang="en-US" sz="1100" dirty="0">
                         <a:latin typeface="Arial" charset="0"/>
                         <a:ea typeface="Arial" charset="0"/>
                         <a:cs typeface="Arial" charset="0"/>
@@ -1720,7 +1720,7 @@
                         <a:buNone/>
                       </a:pPr>
                       <a:r>
-                        <a:rPr lang="en-US" sz="1000" b="1" dirty="0">
+                        <a:rPr lang="en-US" sz="1100" b="1" dirty="0">
                           <a:solidFill>
                             <a:srgbClr val="FFFFFF"/>
                           </a:solidFill>
@@ -1730,7 +1730,7 @@
                         </a:rPr>
                         <a:t>male</a:t>
                       </a:r>
-                      <a:endParaRPr lang="en-US" sz="1000" dirty="0">
+                      <a:endParaRPr lang="en-US" sz="1100" dirty="0">
                         <a:latin typeface="Arial" charset="0"/>
                         <a:ea typeface="Arial" charset="0"/>
                         <a:cs typeface="Arial" charset="0"/>
@@ -1780,7 +1780,7 @@
                   </a:tcPr>
                 </a:tc>
               </a:tr>
-              <a:tr h="320040">
+              <a:tr h="475488">
                 <a:tc>
                   <a:txBody>
                     <a:bodyPr/>
@@ -1790,7 +1790,7 @@
                         <a:buNone/>
                       </a:pPr>
                       <a:r>
-                        <a:rPr lang="en-US" sz="900" b="1" dirty="0">
+                        <a:rPr lang="en-US" sz="1200" b="1" dirty="0">
                           <a:solidFill>
                             <a:srgbClr val="000000"/>
                           </a:solidFill>
@@ -1804,7 +1804,7 @@
                         <a:buNone/>
                       </a:pPr>
                       <a:r>
-                        <a:rPr lang="en-US" sz="900" b="1" dirty="0">
+                        <a:rPr lang="en-US" sz="1200" b="1" dirty="0">
                           <a:solidFill>
                             <a:srgbClr val="000000"/>
                           </a:solidFill>
@@ -1814,7 +1814,7 @@
                         </a:rPr>
                         <a:t>poor</a:t>
                       </a:r>
-                      <a:endParaRPr lang="en-US" sz="900" dirty="0">
+                      <a:endParaRPr lang="en-US" sz="1200" dirty="0">
                         <a:latin typeface="Arial" charset="0"/>
                         <a:ea typeface="Arial" charset="0"/>
                         <a:cs typeface="Arial" charset="0"/>
@@ -1869,7 +1869,7 @@
                         <a:buNone/>
                       </a:pPr>
                       <a:r>
-                        <a:rPr lang="en-US" sz="900" dirty="0">
+                        <a:rPr lang="en-US" sz="1200" dirty="0">
                           <a:solidFill>
                             <a:srgbClr val="000000"/>
                           </a:solidFill>
@@ -1879,7 +1879,7 @@
                         </a:rPr>
                         <a:t>5.3%</a:t>
                       </a:r>
-                      <a:endParaRPr lang="en-US" sz="900" dirty="0">
+                      <a:endParaRPr lang="en-US" sz="1200" dirty="0">
                         <a:latin typeface="Arial" charset="0"/>
                         <a:ea typeface="Arial" charset="0"/>
                         <a:cs typeface="Arial" charset="0"/>
@@ -1934,7 +1934,7 @@
                         <a:buNone/>
                       </a:pPr>
                       <a:r>
-                        <a:rPr lang="en-US" sz="900" dirty="0">
+                        <a:rPr lang="en-US" sz="1200" dirty="0">
                           <a:solidFill>
                             <a:srgbClr val="000000"/>
                           </a:solidFill>
@@ -1944,7 +1944,7 @@
                         </a:rPr>
                         <a:t>2.5%</a:t>
                       </a:r>
-                      <a:endParaRPr lang="en-US" sz="900" dirty="0">
+                      <a:endParaRPr lang="en-US" sz="1200" dirty="0">
                         <a:latin typeface="Arial" charset="0"/>
                         <a:ea typeface="Arial" charset="0"/>
                         <a:cs typeface="Arial" charset="0"/>
@@ -1991,7 +1991,7 @@
                   </a:tcPr>
                 </a:tc>
               </a:tr>
-              <a:tr h="320040">
+              <a:tr h="475488">
                 <a:tc>
                   <a:txBody>
                     <a:bodyPr/>
@@ -2001,7 +2001,7 @@
                         <a:buNone/>
                       </a:pPr>
                       <a:r>
-                        <a:rPr lang="en-US" sz="900" b="1" dirty="0">
+                        <a:rPr lang="en-US" sz="1200" b="1" dirty="0">
                           <a:solidFill>
                             <a:srgbClr val="000000"/>
                           </a:solidFill>
@@ -2011,7 +2011,7 @@
                         </a:rPr>
                         <a:t>poor</a:t>
                       </a:r>
-                      <a:endParaRPr lang="en-US" sz="900" dirty="0">
+                      <a:endParaRPr lang="en-US" sz="1200" dirty="0">
                         <a:latin typeface="Arial" charset="0"/>
                         <a:ea typeface="Arial" charset="0"/>
                         <a:cs typeface="Arial" charset="0"/>
@@ -2066,7 +2066,7 @@
                         <a:buNone/>
                       </a:pPr>
                       <a:r>
-                        <a:rPr lang="en-US" sz="900" dirty="0">
+                        <a:rPr lang="en-US" sz="1200" dirty="0">
                           <a:solidFill>
                             <a:srgbClr val="000000"/>
                           </a:solidFill>
@@ -2076,7 +2076,7 @@
                         </a:rPr>
                         <a:t>7.3%</a:t>
                       </a:r>
-                      <a:endParaRPr lang="en-US" sz="900" dirty="0">
+                      <a:endParaRPr lang="en-US" sz="1200" dirty="0">
                         <a:latin typeface="Arial" charset="0"/>
                         <a:ea typeface="Arial" charset="0"/>
                         <a:cs typeface="Arial" charset="0"/>
@@ -2131,7 +2131,7 @@
                         <a:buNone/>
                       </a:pPr>
                       <a:r>
-                        <a:rPr lang="en-US" sz="900" dirty="0">
+                        <a:rPr lang="en-US" sz="1200" dirty="0">
                           <a:solidFill>
                             <a:srgbClr val="000000"/>
                           </a:solidFill>
@@ -2141,7 +2141,7 @@
                         </a:rPr>
                         <a:t>11.9%</a:t>
                       </a:r>
-                      <a:endParaRPr lang="en-US" sz="900" dirty="0">
+                      <a:endParaRPr lang="en-US" sz="1200" dirty="0">
                         <a:latin typeface="Arial" charset="0"/>
                         <a:ea typeface="Arial" charset="0"/>
                         <a:cs typeface="Arial" charset="0"/>
@@ -2188,7 +2188,7 @@
                   </a:tcPr>
                 </a:tc>
               </a:tr>
-              <a:tr h="320040">
+              <a:tr h="475488">
                 <a:tc>
                   <a:txBody>
                     <a:bodyPr/>
@@ -2198,7 +2198,7 @@
                         <a:buNone/>
                       </a:pPr>
                       <a:r>
-                        <a:rPr lang="en-US" sz="900" b="1" dirty="0">
+                        <a:rPr lang="en-US" sz="1200" b="1" dirty="0">
                           <a:solidFill>
                             <a:srgbClr val="000000"/>
                           </a:solidFill>
@@ -2208,7 +2208,7 @@
                         </a:rPr>
                         <a:t>fair</a:t>
                       </a:r>
-                      <a:endParaRPr lang="en-US" sz="900" dirty="0">
+                      <a:endParaRPr lang="en-US" sz="1200" dirty="0">
                         <a:latin typeface="Arial" charset="0"/>
                         <a:ea typeface="Arial" charset="0"/>
                         <a:cs typeface="Arial" charset="0"/>
@@ -2263,7 +2263,7 @@
                         <a:buNone/>
                       </a:pPr>
                       <a:r>
-                        <a:rPr lang="en-US" sz="900" dirty="0">
+                        <a:rPr lang="en-US" sz="1200" dirty="0">
                           <a:solidFill>
                             <a:srgbClr val="000000"/>
                           </a:solidFill>
@@ -2273,7 +2273,7 @@
                         </a:rPr>
                         <a:t>28.7%</a:t>
                       </a:r>
-                      <a:endParaRPr lang="en-US" sz="900" dirty="0">
+                      <a:endParaRPr lang="en-US" sz="1200" dirty="0">
                         <a:latin typeface="Arial" charset="0"/>
                         <a:ea typeface="Arial" charset="0"/>
                         <a:cs typeface="Arial" charset="0"/>
@@ -2328,7 +2328,7 @@
                         <a:buNone/>
                       </a:pPr>
                       <a:r>
-                        <a:rPr lang="en-US" sz="900" dirty="0">
+                        <a:rPr lang="en-US" sz="1200" dirty="0">
                           <a:solidFill>
                             <a:srgbClr val="000000"/>
                           </a:solidFill>
@@ -2338,7 +2338,7 @@
                         </a:rPr>
                         <a:t>27.1%</a:t>
                       </a:r>
-                      <a:endParaRPr lang="en-US" sz="900" dirty="0">
+                      <a:endParaRPr lang="en-US" sz="1200" dirty="0">
                         <a:latin typeface="Arial" charset="0"/>
                         <a:ea typeface="Arial" charset="0"/>
                         <a:cs typeface="Arial" charset="0"/>
@@ -2385,7 +2385,7 @@
                   </a:tcPr>
                 </a:tc>
               </a:tr>
-              <a:tr h="320040">
+              <a:tr h="475488">
                 <a:tc>
                   <a:txBody>
                     <a:bodyPr/>
@@ -2395,7 +2395,7 @@
                         <a:buNone/>
                       </a:pPr>
                       <a:r>
-                        <a:rPr lang="en-US" sz="900" b="1" dirty="0">
+                        <a:rPr lang="en-US" sz="1200" b="1" dirty="0">
                           <a:solidFill>
                             <a:srgbClr val="000000"/>
                           </a:solidFill>
@@ -2405,7 +2405,7 @@
                         </a:rPr>
                         <a:t>good</a:t>
                       </a:r>
-                      <a:endParaRPr lang="en-US" sz="900" dirty="0">
+                      <a:endParaRPr lang="en-US" sz="1200" dirty="0">
                         <a:latin typeface="Arial" charset="0"/>
                         <a:ea typeface="Arial" charset="0"/>
                         <a:cs typeface="Arial" charset="0"/>
@@ -2460,7 +2460,7 @@
                         <a:buNone/>
                       </a:pPr>
                       <a:r>
-                        <a:rPr lang="en-US" sz="900" dirty="0">
+                        <a:rPr lang="en-US" sz="1200" dirty="0">
                           <a:solidFill>
                             <a:srgbClr val="000000"/>
                           </a:solidFill>
@@ -2474,7 +2474,7 @@
                         <a:buNone/>
                       </a:pPr>
                       <a:r>
-                        <a:rPr lang="en-US" sz="900" dirty="0">
+                        <a:rPr lang="en-US" sz="1200" dirty="0">
                           <a:solidFill>
                             <a:srgbClr val="000000"/>
                           </a:solidFill>
@@ -2484,7 +2484,7 @@
                         </a:rPr>
                         <a:t>△</a:t>
                       </a:r>
-                      <a:endParaRPr lang="en-US" sz="900" dirty="0">
+                      <a:endParaRPr lang="en-US" sz="1200" dirty="0">
                         <a:latin typeface="Arial" charset="0"/>
                         <a:ea typeface="Arial" charset="0"/>
                         <a:cs typeface="Arial" charset="0"/>
@@ -2539,7 +2539,7 @@
                         <a:buNone/>
                       </a:pPr>
                       <a:r>
-                        <a:rPr lang="en-US" sz="900" dirty="0">
+                        <a:rPr lang="en-US" sz="1200" dirty="0">
                           <a:solidFill>
                             <a:srgbClr val="000000"/>
                           </a:solidFill>
@@ -2549,7 +2549,7 @@
                         </a:rPr>
                         <a:t>28.0%</a:t>
                       </a:r>
-                      <a:endParaRPr lang="en-US" sz="900" dirty="0">
+                      <a:endParaRPr lang="en-US" sz="1200" dirty="0">
                         <a:latin typeface="Arial" charset="0"/>
                         <a:ea typeface="Arial" charset="0"/>
                         <a:cs typeface="Arial" charset="0"/>
@@ -2596,7 +2596,7 @@
                   </a:tcPr>
                 </a:tc>
               </a:tr>
-              <a:tr h="320040">
+              <a:tr h="475488">
                 <a:tc>
                   <a:txBody>
                     <a:bodyPr/>
@@ -2606,7 +2606,7 @@
                         <a:buNone/>
                       </a:pPr>
                       <a:r>
-                        <a:rPr lang="en-US" sz="900" b="1" dirty="0">
+                        <a:rPr lang="en-US" sz="1200" b="1" dirty="0">
                           <a:solidFill>
                             <a:srgbClr val="000000"/>
                           </a:solidFill>
@@ -2620,7 +2620,7 @@
                         <a:buNone/>
                       </a:pPr>
                       <a:r>
-                        <a:rPr lang="en-US" sz="900" b="1" dirty="0">
+                        <a:rPr lang="en-US" sz="1200" b="1" dirty="0">
                           <a:solidFill>
                             <a:srgbClr val="000000"/>
                           </a:solidFill>
@@ -2630,7 +2630,7 @@
                         </a:rPr>
                         <a:t>good</a:t>
                       </a:r>
-                      <a:endParaRPr lang="en-US" sz="900" dirty="0">
+                      <a:endParaRPr lang="en-US" sz="1200" dirty="0">
                         <a:latin typeface="Arial" charset="0"/>
                         <a:ea typeface="Arial" charset="0"/>
                         <a:cs typeface="Arial" charset="0"/>
@@ -2685,7 +2685,7 @@
                         <a:buNone/>
                       </a:pPr>
                       <a:r>
-                        <a:rPr lang="en-US" sz="900" dirty="0">
+                        <a:rPr lang="en-US" sz="1200" dirty="0">
                           <a:solidFill>
                             <a:srgbClr val="000000"/>
                           </a:solidFill>
@@ -2695,7 +2695,7 @@
                         </a:rPr>
                         <a:t>17.3%</a:t>
                       </a:r>
-                      <a:endParaRPr lang="en-US" sz="900" dirty="0">
+                      <a:endParaRPr lang="en-US" sz="1200" dirty="0">
                         <a:latin typeface="Arial" charset="0"/>
                         <a:ea typeface="Arial" charset="0"/>
                         <a:cs typeface="Arial" charset="0"/>
@@ -2750,7 +2750,7 @@
                         <a:buNone/>
                       </a:pPr>
                       <a:r>
-                        <a:rPr lang="en-US" sz="900" dirty="0">
+                        <a:rPr lang="en-US" sz="1200" dirty="0">
                           <a:solidFill>
                             <a:srgbClr val="000000"/>
                           </a:solidFill>
@@ -2760,7 +2760,7 @@
                         </a:rPr>
                         <a:t>26.3%</a:t>
                       </a:r>
-                      <a:endParaRPr lang="en-US" sz="900" dirty="0">
+                      <a:endParaRPr lang="en-US" sz="1200" dirty="0">
                         <a:latin typeface="Arial" charset="0"/>
                         <a:ea typeface="Arial" charset="0"/>
                         <a:cs typeface="Arial" charset="0"/>
@@ -2807,7 +2807,7 @@
                   </a:tcPr>
                 </a:tc>
               </a:tr>
-              <a:tr h="320040">
+              <a:tr h="475488">
                 <a:tc>
                   <a:txBody>
                     <a:bodyPr/>
@@ -2817,7 +2817,7 @@
                         <a:buNone/>
                       </a:pPr>
                       <a:r>
-                        <a:rPr lang="en-US" sz="900" b="1" dirty="0">
+                        <a:rPr lang="en-US" sz="1200" b="1" dirty="0">
                           <a:solidFill>
                             <a:srgbClr val="000000"/>
                           </a:solidFill>
@@ -2827,7 +2827,7 @@
                         </a:rPr>
                         <a:t>excellent</a:t>
                       </a:r>
-                      <a:endParaRPr lang="en-US" sz="900" dirty="0">
+                      <a:endParaRPr lang="en-US" sz="1200" dirty="0">
                         <a:latin typeface="Arial" charset="0"/>
                         <a:ea typeface="Arial" charset="0"/>
                         <a:cs typeface="Arial" charset="0"/>
@@ -2882,7 +2882,7 @@
                         <a:buNone/>
                       </a:pPr>
                       <a:r>
-                        <a:rPr lang="en-US" sz="900" dirty="0">
+                        <a:rPr lang="en-US" sz="1200" dirty="0">
                           <a:solidFill>
                             <a:srgbClr val="000000"/>
                           </a:solidFill>
@@ -2892,7 +2892,7 @@
                         </a:rPr>
                         <a:t>3.3%</a:t>
                       </a:r>
-                      <a:endParaRPr lang="en-US" sz="900" dirty="0">
+                      <a:endParaRPr lang="en-US" sz="1200" dirty="0">
                         <a:latin typeface="Arial" charset="0"/>
                         <a:ea typeface="Arial" charset="0"/>
                         <a:cs typeface="Arial" charset="0"/>
@@ -2947,7 +2947,7 @@
                         <a:buNone/>
                       </a:pPr>
                       <a:r>
-                        <a:rPr lang="en-US" sz="900" dirty="0">
+                        <a:rPr lang="en-US" sz="1200" dirty="0">
                           <a:solidFill>
                             <a:srgbClr val="000000"/>
                           </a:solidFill>
@@ -2957,7 +2957,7 @@
                         </a:rPr>
                         <a:t>4.2%</a:t>
                       </a:r>
-                      <a:endParaRPr lang="en-US" sz="900" dirty="0">
+                      <a:endParaRPr lang="en-US" sz="1200" dirty="0">
                         <a:latin typeface="Arial" charset="0"/>
                         <a:ea typeface="Arial" charset="0"/>
                         <a:cs typeface="Arial" charset="0"/>
@@ -3041,8 +3041,8 @@
         </p:nvSpPr>
         <p:spPr>
           <a:xfrm>
-            <a:off x="457200" y="274320"/>
-            <a:ext cx="10972800" cy="0"/>
+            <a:off x="640080" y="274320"/>
+            <a:ext cx="10881360" cy="822960"/>
           </a:xfrm>
           <a:prstGeom prst="rect">
             <a:avLst/>
@@ -3058,7 +3058,7 @@
               <a:buNone/>
             </a:pPr>
             <a:r>
-              <a:rPr lang="en-US" sz="1800" b="1" dirty="0">
+              <a:rPr lang="en-US" sz="2000" b="1" dirty="0">
                 <a:solidFill>
                   <a:srgbClr val="17212B"/>
                 </a:solidFill>
@@ -3068,7 +3068,7 @@
               </a:rPr>
               <a:t>Epworth Sleepiness Scale by Marital Status</a:t>
             </a:r>
-            <a:endParaRPr lang="en-US" sz="1800" dirty="0"/>
+            <a:endParaRPr lang="en-US" sz="2000" dirty="0"/>
           </a:p>
         </p:txBody>
       </p:sp>
@@ -3080,8 +3080,8 @@
         </p:nvSpPr>
         <p:spPr>
           <a:xfrm>
-            <a:off x="457200" y="621792"/>
-            <a:ext cx="10972800" cy="0"/>
+            <a:off x="640080" y="6309360"/>
+            <a:ext cx="10881360" cy="347472"/>
           </a:xfrm>
           <a:prstGeom prst="rect">
             <a:avLst/>
@@ -3097,7 +3097,7 @@
               <a:buNone/>
             </a:pPr>
             <a:r>
-              <a:rPr lang="en-US" sz="1000" dirty="0">
+              <a:rPr lang="en-US" sz="900" dirty="0">
                 <a:solidFill>
                   <a:srgbClr val="666666"/>
                 </a:solidFill>
@@ -3107,7 +3107,7 @@
               </a:rPr>
               <a:t>N = 271 Respondents</a:t>
             </a:r>
-            <a:endParaRPr lang="en-US" sz="1000" dirty="0"/>
+            <a:endParaRPr lang="en-US" sz="900" dirty="0"/>
           </a:p>
         </p:txBody>
       </p:sp>
@@ -3126,18 +3126,18 @@
           </p:nvPr>
         </p:nvGraphicFramePr>
         <p:xfrm>
-          <a:off x="457200" y="1188720"/>
-          <a:ext cx="11247120" cy="914400"/>
+          <a:off x="640080" y="1600200"/>
+          <a:ext cx="8869680" cy="914400"/>
         </p:xfrm>
         <a:graphic>
           <a:graphicData uri="http://schemas.openxmlformats.org/drawingml/2006/table">
             <a:tbl>
               <a:tblPr/>
               <a:tblGrid>
-                <a:gridCol w="2743200"/>
-                <a:gridCol w="8503920"/>
+                <a:gridCol w="2926080"/>
+                <a:gridCol w="5943600"/>
               </a:tblGrid>
-              <a:tr h="320040">
+              <a:tr h="475488">
                 <a:tc>
                   <a:txBody>
                     <a:bodyPr/>
@@ -3146,7 +3146,7 @@
                       <a:pPr indent="0" marL="0">
                         <a:buNone/>
                       </a:pPr>
-                      <a:endParaRPr lang="en-US" sz="1000" dirty="0">
+                      <a:endParaRPr lang="en-US" sz="1100" dirty="0">
                         <a:latin typeface="Arial" charset="0"/>
                         <a:ea typeface="Arial" charset="0"/>
                         <a:cs typeface="Arial" charset="0"/>
@@ -3204,7 +3204,7 @@
                         <a:buNone/>
                       </a:pPr>
                       <a:r>
-                        <a:rPr lang="en-US" sz="1000" b="1" dirty="0">
+                        <a:rPr lang="en-US" sz="1100" b="1" dirty="0">
                           <a:solidFill>
                             <a:srgbClr val="FFFFFF"/>
                           </a:solidFill>
@@ -3218,7 +3218,7 @@
                         <a:buNone/>
                       </a:pPr>
                       <a:r>
-                        <a:rPr lang="en-US" sz="1000" b="1" dirty="0">
+                        <a:rPr lang="en-US" sz="1100" b="1" dirty="0">
                           <a:solidFill>
                             <a:srgbClr val="FFFFFF"/>
                           </a:solidFill>
@@ -3232,7 +3232,7 @@
                         <a:buNone/>
                       </a:pPr>
                       <a:r>
-                        <a:rPr lang="en-US" sz="1000" b="1" dirty="0">
+                        <a:rPr lang="en-US" sz="1100" b="1" dirty="0">
                           <a:solidFill>
                             <a:srgbClr val="FFFFFF"/>
                           </a:solidFill>
@@ -3242,7 +3242,7 @@
                         </a:rPr>
                         <a:t>scale</a:t>
                       </a:r>
-                      <a:endParaRPr lang="en-US" sz="1000" dirty="0">
+                      <a:endParaRPr lang="en-US" sz="1100" dirty="0">
                         <a:latin typeface="Arial" charset="0"/>
                         <a:ea typeface="Arial" charset="0"/>
                         <a:cs typeface="Arial" charset="0"/>
@@ -3292,7 +3292,7 @@
                   </a:tcPr>
                 </a:tc>
               </a:tr>
-              <a:tr h="320040">
+              <a:tr h="475488">
                 <a:tc>
                   <a:txBody>
                     <a:bodyPr/>
@@ -3302,7 +3302,7 @@
                         <a:buNone/>
                       </a:pPr>
                       <a:r>
-                        <a:rPr lang="en-US" sz="900" b="1" dirty="0">
+                        <a:rPr lang="en-US" sz="1200" b="1" dirty="0">
                           <a:solidFill>
                             <a:srgbClr val="000000"/>
                           </a:solidFill>
@@ -3312,7 +3312,7 @@
                         </a:rPr>
                         <a:t>1</a:t>
                       </a:r>
-                      <a:endParaRPr lang="en-US" sz="900" dirty="0">
+                      <a:endParaRPr lang="en-US" sz="1200" dirty="0">
                         <a:latin typeface="Arial" charset="0"/>
                         <a:ea typeface="Arial" charset="0"/>
                         <a:cs typeface="Arial" charset="0"/>
@@ -3367,7 +3367,7 @@
                         <a:buNone/>
                       </a:pPr>
                       <a:r>
-                        <a:rPr lang="en-US" sz="900" dirty="0">
+                        <a:rPr lang="en-US" sz="1200" dirty="0">
                           <a:solidFill>
                             <a:srgbClr val="000000"/>
                           </a:solidFill>
@@ -3377,7 +3377,7 @@
                         </a:rPr>
                         <a:t>21.2%</a:t>
                       </a:r>
-                      <a:endParaRPr lang="en-US" sz="900" dirty="0">
+                      <a:endParaRPr lang="en-US" sz="1200" dirty="0">
                         <a:latin typeface="Arial" charset="0"/>
                         <a:ea typeface="Arial" charset="0"/>
                         <a:cs typeface="Arial" charset="0"/>
@@ -3424,7 +3424,7 @@
                   </a:tcPr>
                 </a:tc>
               </a:tr>
-              <a:tr h="320040">
+              <a:tr h="475488">
                 <a:tc>
                   <a:txBody>
                     <a:bodyPr/>
@@ -3434,7 +3434,7 @@
                         <a:buNone/>
                       </a:pPr>
                       <a:r>
-                        <a:rPr lang="en-US" sz="900" b="1" dirty="0">
+                        <a:rPr lang="en-US" sz="1200" b="1" dirty="0">
                           <a:solidFill>
                             <a:srgbClr val="000000"/>
                           </a:solidFill>
@@ -3444,7 +3444,7 @@
                         </a:rPr>
                         <a:t>2</a:t>
                       </a:r>
-                      <a:endParaRPr lang="en-US" sz="900" dirty="0">
+                      <a:endParaRPr lang="en-US" sz="1200" dirty="0">
                         <a:latin typeface="Arial" charset="0"/>
                         <a:ea typeface="Arial" charset="0"/>
                         <a:cs typeface="Arial" charset="0"/>
@@ -3499,7 +3499,7 @@
                         <a:buNone/>
                       </a:pPr>
                       <a:r>
-                        <a:rPr lang="en-US" sz="900" dirty="0">
+                        <a:rPr lang="en-US" sz="1200" dirty="0">
                           <a:solidFill>
                             <a:srgbClr val="000000"/>
                           </a:solidFill>
@@ -3509,7 +3509,7 @@
                         </a:rPr>
                         <a:t>69.0%</a:t>
                       </a:r>
-                      <a:endParaRPr lang="en-US" sz="900" dirty="0">
+                      <a:endParaRPr lang="en-US" sz="1200" dirty="0">
                         <a:latin typeface="Arial" charset="0"/>
                         <a:ea typeface="Arial" charset="0"/>
                         <a:cs typeface="Arial" charset="0"/>
@@ -3556,7 +3556,7 @@
                   </a:tcPr>
                 </a:tc>
               </a:tr>
-              <a:tr h="320040">
+              <a:tr h="475488">
                 <a:tc>
                   <a:txBody>
                     <a:bodyPr/>
@@ -3566,7 +3566,7 @@
                         <a:buNone/>
                       </a:pPr>
                       <a:r>
-                        <a:rPr lang="en-US" sz="900" b="1" dirty="0">
+                        <a:rPr lang="en-US" sz="1200" b="1" dirty="0">
                           <a:solidFill>
                             <a:srgbClr val="000000"/>
                           </a:solidFill>
@@ -3576,7 +3576,7 @@
                         </a:rPr>
                         <a:t>3</a:t>
                       </a:r>
-                      <a:endParaRPr lang="en-US" sz="900" dirty="0">
+                      <a:endParaRPr lang="en-US" sz="1200" dirty="0">
                         <a:latin typeface="Arial" charset="0"/>
                         <a:ea typeface="Arial" charset="0"/>
                         <a:cs typeface="Arial" charset="0"/>
@@ -3631,7 +3631,7 @@
                         <a:buNone/>
                       </a:pPr>
                       <a:r>
-                        <a:rPr lang="en-US" sz="900" dirty="0">
+                        <a:rPr lang="en-US" sz="1200" dirty="0">
                           <a:solidFill>
                             <a:srgbClr val="000000"/>
                           </a:solidFill>
@@ -3641,7 +3641,7 @@
                         </a:rPr>
                         <a:t>7.8%</a:t>
                       </a:r>
-                      <a:endParaRPr lang="en-US" sz="900" dirty="0">
+                      <a:endParaRPr lang="en-US" sz="1200" dirty="0">
                         <a:latin typeface="Arial" charset="0"/>
                         <a:ea typeface="Arial" charset="0"/>
                         <a:cs typeface="Arial" charset="0"/>
@@ -3688,7 +3688,7 @@
                   </a:tcPr>
                 </a:tc>
               </a:tr>
-              <a:tr h="320040">
+              <a:tr h="475488">
                 <a:tc>
                   <a:txBody>
                     <a:bodyPr/>
@@ -3698,7 +3698,7 @@
                         <a:buNone/>
                       </a:pPr>
                       <a:r>
-                        <a:rPr lang="en-US" sz="900" b="1" dirty="0">
+                        <a:rPr lang="en-US" sz="1200" b="1" dirty="0">
                           <a:solidFill>
                             <a:srgbClr val="000000"/>
                           </a:solidFill>
@@ -3708,7 +3708,7 @@
                         </a:rPr>
                         <a:t>4</a:t>
                       </a:r>
-                      <a:endParaRPr lang="en-US" sz="900" dirty="0">
+                      <a:endParaRPr lang="en-US" sz="1200" dirty="0">
                         <a:latin typeface="Arial" charset="0"/>
                         <a:ea typeface="Arial" charset="0"/>
                         <a:cs typeface="Arial" charset="0"/>
@@ -3763,7 +3763,7 @@
                         <a:buNone/>
                       </a:pPr>
                       <a:r>
-                        <a:rPr lang="en-US" sz="900" dirty="0">
+                        <a:rPr lang="en-US" sz="1200" dirty="0">
                           <a:solidFill>
                             <a:srgbClr val="000000"/>
                           </a:solidFill>
@@ -3773,7 +3773,7 @@
                         </a:rPr>
                         <a:t>2.0%</a:t>
                       </a:r>
-                      <a:endParaRPr lang="en-US" sz="900" dirty="0">
+                      <a:endParaRPr lang="en-US" sz="1200" dirty="0">
                         <a:latin typeface="Arial" charset="0"/>
                         <a:ea typeface="Arial" charset="0"/>
                         <a:cs typeface="Arial" charset="0"/>
@@ -3960,8 +3960,8 @@
         </p:nvSpPr>
         <p:spPr>
           <a:xfrm>
-            <a:off x="457200" y="274320"/>
-            <a:ext cx="10972800" cy="0"/>
+            <a:off x="640080" y="274320"/>
+            <a:ext cx="10881360" cy="822960"/>
           </a:xfrm>
           <a:prstGeom prst="rect">
             <a:avLst/>
@@ -3977,7 +3977,7 @@
               <a:buNone/>
             </a:pPr>
             <a:r>
-              <a:rPr lang="en-US" sz="1800" b="1" dirty="0">
+              <a:rPr lang="en-US" sz="2000" b="1" dirty="0">
                 <a:solidFill>
                   <a:srgbClr val="17212B"/>
                 </a:solidFill>
@@ -3987,7 +3987,7 @@
               </a:rPr>
               <a:t>HADS Anxiety by Gender</a:t>
             </a:r>
-            <a:endParaRPr lang="en-US" sz="1800" dirty="0"/>
+            <a:endParaRPr lang="en-US" sz="2000" dirty="0"/>
           </a:p>
         </p:txBody>
       </p:sp>
@@ -3999,8 +3999,8 @@
         </p:nvSpPr>
         <p:spPr>
           <a:xfrm>
-            <a:off x="457200" y="621792"/>
-            <a:ext cx="10972800" cy="0"/>
+            <a:off x="640080" y="6309360"/>
+            <a:ext cx="10881360" cy="347472"/>
           </a:xfrm>
           <a:prstGeom prst="rect">
             <a:avLst/>
@@ -4016,7 +4016,7 @@
               <a:buNone/>
             </a:pPr>
             <a:r>
-              <a:rPr lang="en-US" sz="1000" dirty="0">
+              <a:rPr lang="en-US" sz="900" dirty="0">
                 <a:solidFill>
                   <a:srgbClr val="666666"/>
                 </a:solidFill>
@@ -4026,7 +4026,7 @@
               </a:rPr>
               <a:t>N = 271 Respondents</a:t>
             </a:r>
-            <a:endParaRPr lang="en-US" sz="1000" dirty="0"/>
+            <a:endParaRPr lang="en-US" sz="900" dirty="0"/>
           </a:p>
         </p:txBody>
       </p:sp>
@@ -4045,18 +4045,18 @@
           </p:nvPr>
         </p:nvGraphicFramePr>
         <p:xfrm>
-          <a:off x="457200" y="1188720"/>
-          <a:ext cx="11247120" cy="914400"/>
+          <a:off x="640080" y="1600200"/>
+          <a:ext cx="8869680" cy="914400"/>
         </p:xfrm>
         <a:graphic>
           <a:graphicData uri="http://schemas.openxmlformats.org/drawingml/2006/table">
             <a:tbl>
               <a:tblPr/>
               <a:tblGrid>
-                <a:gridCol w="2743200"/>
-                <a:gridCol w="8503920"/>
+                <a:gridCol w="2926080"/>
+                <a:gridCol w="5943600"/>
               </a:tblGrid>
-              <a:tr h="320040">
+              <a:tr h="475488">
                 <a:tc>
                   <a:txBody>
                     <a:bodyPr/>
@@ -4065,7 +4065,7 @@
                       <a:pPr indent="0" marL="0">
                         <a:buNone/>
                       </a:pPr>
-                      <a:endParaRPr lang="en-US" sz="1000" dirty="0">
+                      <a:endParaRPr lang="en-US" sz="1100" dirty="0">
                         <a:latin typeface="Arial" charset="0"/>
                         <a:ea typeface="Arial" charset="0"/>
                         <a:cs typeface="Arial" charset="0"/>
@@ -4123,7 +4123,7 @@
                         <a:buNone/>
                       </a:pPr>
                       <a:r>
-                        <a:rPr lang="en-US" sz="1000" b="1" dirty="0">
+                        <a:rPr lang="en-US" sz="1100" b="1" dirty="0">
                           <a:solidFill>
                             <a:srgbClr val="FFFFFF"/>
                           </a:solidFill>
@@ -4137,7 +4137,7 @@
                         <a:buNone/>
                       </a:pPr>
                       <a:r>
-                        <a:rPr lang="en-US" sz="1000" b="1" dirty="0">
+                        <a:rPr lang="en-US" sz="1100" b="1" dirty="0">
                           <a:solidFill>
                             <a:srgbClr val="FFFFFF"/>
                           </a:solidFill>
@@ -4147,7 +4147,7 @@
                         </a:rPr>
                         <a:t>Anxiety</a:t>
                       </a:r>
-                      <a:endParaRPr lang="en-US" sz="1000" dirty="0">
+                      <a:endParaRPr lang="en-US" sz="1100" dirty="0">
                         <a:latin typeface="Arial" charset="0"/>
                         <a:ea typeface="Arial" charset="0"/>
                         <a:cs typeface="Arial" charset="0"/>
@@ -4197,7 +4197,7 @@
                   </a:tcPr>
                 </a:tc>
               </a:tr>
-              <a:tr h="320040">
+              <a:tr h="475488">
                 <a:tc>
                   <a:txBody>
                     <a:bodyPr/>
@@ -4207,7 +4207,7 @@
                         <a:buNone/>
                       </a:pPr>
                       <a:r>
-                        <a:rPr lang="en-US" sz="900" b="1" dirty="0">
+                        <a:rPr lang="en-US" sz="1200" b="1" dirty="0">
                           <a:solidFill>
                             <a:srgbClr val="000000"/>
                           </a:solidFill>
@@ -4217,7 +4217,7 @@
                         </a:rPr>
                         <a:t>0</a:t>
                       </a:r>
-                      <a:endParaRPr lang="en-US" sz="900" dirty="0">
+                      <a:endParaRPr lang="en-US" sz="1200" dirty="0">
                         <a:latin typeface="Arial" charset="0"/>
                         <a:ea typeface="Arial" charset="0"/>
                         <a:cs typeface="Arial" charset="0"/>
@@ -4272,7 +4272,7 @@
                         <a:buNone/>
                       </a:pPr>
                       <a:r>
-                        <a:rPr lang="en-US" sz="900" dirty="0">
+                        <a:rPr lang="en-US" sz="1200" dirty="0">
                           <a:solidFill>
                             <a:srgbClr val="000000"/>
                           </a:solidFill>
@@ -4282,7 +4282,7 @@
                         </a:rPr>
                         <a:t>54.9%</a:t>
                       </a:r>
-                      <a:endParaRPr lang="en-US" sz="900" dirty="0">
+                      <a:endParaRPr lang="en-US" sz="1200" dirty="0">
                         <a:latin typeface="Arial" charset="0"/>
                         <a:ea typeface="Arial" charset="0"/>
                         <a:cs typeface="Arial" charset="0"/>
@@ -4329,7 +4329,7 @@
                   </a:tcPr>
                 </a:tc>
               </a:tr>
-              <a:tr h="320040">
+              <a:tr h="475488">
                 <a:tc>
                   <a:txBody>
                     <a:bodyPr/>
@@ -4339,7 +4339,7 @@
                         <a:buNone/>
                       </a:pPr>
                       <a:r>
-                        <a:rPr lang="en-US" sz="900" b="1" dirty="0">
+                        <a:rPr lang="en-US" sz="1200" b="1" dirty="0">
                           <a:solidFill>
                             <a:srgbClr val="000000"/>
                           </a:solidFill>
@@ -4349,7 +4349,7 @@
                         </a:rPr>
                         <a:t>1</a:t>
                       </a:r>
-                      <a:endParaRPr lang="en-US" sz="900" dirty="0">
+                      <a:endParaRPr lang="en-US" sz="1200" dirty="0">
                         <a:latin typeface="Arial" charset="0"/>
                         <a:ea typeface="Arial" charset="0"/>
                         <a:cs typeface="Arial" charset="0"/>
@@ -4404,7 +4404,7 @@
                         <a:buNone/>
                       </a:pPr>
                       <a:r>
-                        <a:rPr lang="en-US" sz="900" dirty="0">
+                        <a:rPr lang="en-US" sz="1200" dirty="0">
                           <a:solidFill>
                             <a:srgbClr val="000000"/>
                           </a:solidFill>
@@ -4414,7 +4414,7 @@
                         </a:rPr>
                         <a:t>45.1%</a:t>
                       </a:r>
-                      <a:endParaRPr lang="en-US" sz="900" dirty="0">
+                      <a:endParaRPr lang="en-US" sz="1200" dirty="0">
                         <a:latin typeface="Arial" charset="0"/>
                         <a:ea typeface="Arial" charset="0"/>
                         <a:cs typeface="Arial" charset="0"/>

</xml_diff>